<commit_message>
updated with payment and user customer management
</commit_message>
<xml_diff>
--- a/betchaBooking-USECASE.pptx
+++ b/betchaBooking-USECASE.pptx
@@ -22,41 +22,42 @@
     <p:sldId id="268" r:id="rId16"/>
     <p:sldId id="269" r:id="rId17"/>
     <p:sldId id="271" r:id="rId18"/>
-    <p:sldId id="270" r:id="rId19"/>
-    <p:sldId id="287" r:id="rId20"/>
-    <p:sldId id="276" r:id="rId21"/>
-    <p:sldId id="278" r:id="rId22"/>
-    <p:sldId id="277" r:id="rId23"/>
-    <p:sldId id="272" r:id="rId24"/>
-    <p:sldId id="275" r:id="rId25"/>
-    <p:sldId id="273" r:id="rId26"/>
-    <p:sldId id="274" r:id="rId27"/>
-    <p:sldId id="279" r:id="rId28"/>
-    <p:sldId id="280" r:id="rId29"/>
-    <p:sldId id="281" r:id="rId30"/>
-    <p:sldId id="282" r:id="rId31"/>
-    <p:sldId id="283" r:id="rId32"/>
-    <p:sldId id="285" r:id="rId33"/>
-    <p:sldId id="286" r:id="rId34"/>
-    <p:sldId id="290" r:id="rId35"/>
-    <p:sldId id="291" r:id="rId36"/>
-    <p:sldId id="289" r:id="rId37"/>
-    <p:sldId id="292" r:id="rId38"/>
-    <p:sldId id="293" r:id="rId39"/>
-    <p:sldId id="294" r:id="rId40"/>
-    <p:sldId id="295" r:id="rId41"/>
-    <p:sldId id="296" r:id="rId42"/>
-    <p:sldId id="297" r:id="rId43"/>
-    <p:sldId id="299" r:id="rId44"/>
-    <p:sldId id="300" r:id="rId45"/>
-    <p:sldId id="309" r:id="rId46"/>
-    <p:sldId id="306" r:id="rId47"/>
-    <p:sldId id="307" r:id="rId48"/>
-    <p:sldId id="302" r:id="rId49"/>
-    <p:sldId id="308" r:id="rId50"/>
-    <p:sldId id="301" r:id="rId51"/>
-    <p:sldId id="303" r:id="rId52"/>
-    <p:sldId id="304" r:id="rId53"/>
+    <p:sldId id="310" r:id="rId19"/>
+    <p:sldId id="270" r:id="rId20"/>
+    <p:sldId id="287" r:id="rId21"/>
+    <p:sldId id="276" r:id="rId22"/>
+    <p:sldId id="278" r:id="rId23"/>
+    <p:sldId id="277" r:id="rId24"/>
+    <p:sldId id="272" r:id="rId25"/>
+    <p:sldId id="275" r:id="rId26"/>
+    <p:sldId id="273" r:id="rId27"/>
+    <p:sldId id="274" r:id="rId28"/>
+    <p:sldId id="279" r:id="rId29"/>
+    <p:sldId id="280" r:id="rId30"/>
+    <p:sldId id="281" r:id="rId31"/>
+    <p:sldId id="282" r:id="rId32"/>
+    <p:sldId id="283" r:id="rId33"/>
+    <p:sldId id="285" r:id="rId34"/>
+    <p:sldId id="286" r:id="rId35"/>
+    <p:sldId id="290" r:id="rId36"/>
+    <p:sldId id="291" r:id="rId37"/>
+    <p:sldId id="289" r:id="rId38"/>
+    <p:sldId id="292" r:id="rId39"/>
+    <p:sldId id="293" r:id="rId40"/>
+    <p:sldId id="294" r:id="rId41"/>
+    <p:sldId id="295" r:id="rId42"/>
+    <p:sldId id="296" r:id="rId43"/>
+    <p:sldId id="297" r:id="rId44"/>
+    <p:sldId id="299" r:id="rId45"/>
+    <p:sldId id="300" r:id="rId46"/>
+    <p:sldId id="309" r:id="rId47"/>
+    <p:sldId id="306" r:id="rId48"/>
+    <p:sldId id="307" r:id="rId49"/>
+    <p:sldId id="302" r:id="rId50"/>
+    <p:sldId id="308" r:id="rId51"/>
+    <p:sldId id="301" r:id="rId52"/>
+    <p:sldId id="303" r:id="rId53"/>
+    <p:sldId id="304" r:id="rId54"/>
   </p:sldIdLst>
   <p:sldSz cx="12192000" cy="6858000"/>
   <p:notesSz cx="6858000" cy="9144000"/>
@@ -310,7 +311,7 @@
           <a:p>
             <a:fld id="{D723CA93-4BBF-43AB-A538-39903E4C269C}" type="datetimeFigureOut">
               <a:rPr lang="en-US" smtClean="0"/>
-              <a:t>4/18/2025</a:t>
+              <a:t>5/11/2025</a:t>
             </a:fld>
             <a:endParaRPr lang="en-US"/>
           </a:p>
@@ -508,7 +509,7 @@
           <a:p>
             <a:fld id="{D723CA93-4BBF-43AB-A538-39903E4C269C}" type="datetimeFigureOut">
               <a:rPr lang="en-US" smtClean="0"/>
-              <a:t>4/18/2025</a:t>
+              <a:t>5/11/2025</a:t>
             </a:fld>
             <a:endParaRPr lang="en-US"/>
           </a:p>
@@ -716,7 +717,7 @@
           <a:p>
             <a:fld id="{D723CA93-4BBF-43AB-A538-39903E4C269C}" type="datetimeFigureOut">
               <a:rPr lang="en-US" smtClean="0"/>
-              <a:t>4/18/2025</a:t>
+              <a:t>5/11/2025</a:t>
             </a:fld>
             <a:endParaRPr lang="en-US"/>
           </a:p>
@@ -914,7 +915,7 @@
           <a:p>
             <a:fld id="{D723CA93-4BBF-43AB-A538-39903E4C269C}" type="datetimeFigureOut">
               <a:rPr lang="en-US" smtClean="0"/>
-              <a:t>4/18/2025</a:t>
+              <a:t>5/11/2025</a:t>
             </a:fld>
             <a:endParaRPr lang="en-US"/>
           </a:p>
@@ -1189,7 +1190,7 @@
           <a:p>
             <a:fld id="{D723CA93-4BBF-43AB-A538-39903E4C269C}" type="datetimeFigureOut">
               <a:rPr lang="en-US" smtClean="0"/>
-              <a:t>4/18/2025</a:t>
+              <a:t>5/11/2025</a:t>
             </a:fld>
             <a:endParaRPr lang="en-US"/>
           </a:p>
@@ -1454,7 +1455,7 @@
           <a:p>
             <a:fld id="{D723CA93-4BBF-43AB-A538-39903E4C269C}" type="datetimeFigureOut">
               <a:rPr lang="en-US" smtClean="0"/>
-              <a:t>4/18/2025</a:t>
+              <a:t>5/11/2025</a:t>
             </a:fld>
             <a:endParaRPr lang="en-US"/>
           </a:p>
@@ -1866,7 +1867,7 @@
           <a:p>
             <a:fld id="{D723CA93-4BBF-43AB-A538-39903E4C269C}" type="datetimeFigureOut">
               <a:rPr lang="en-US" smtClean="0"/>
-              <a:t>4/18/2025</a:t>
+              <a:t>5/11/2025</a:t>
             </a:fld>
             <a:endParaRPr lang="en-US"/>
           </a:p>
@@ -2007,7 +2008,7 @@
           <a:p>
             <a:fld id="{D723CA93-4BBF-43AB-A538-39903E4C269C}" type="datetimeFigureOut">
               <a:rPr lang="en-US" smtClean="0"/>
-              <a:t>4/18/2025</a:t>
+              <a:t>5/11/2025</a:t>
             </a:fld>
             <a:endParaRPr lang="en-US"/>
           </a:p>
@@ -2120,7 +2121,7 @@
           <a:p>
             <a:fld id="{D723CA93-4BBF-43AB-A538-39903E4C269C}" type="datetimeFigureOut">
               <a:rPr lang="en-US" smtClean="0"/>
-              <a:t>4/18/2025</a:t>
+              <a:t>5/11/2025</a:t>
             </a:fld>
             <a:endParaRPr lang="en-US"/>
           </a:p>
@@ -2431,7 +2432,7 @@
           <a:p>
             <a:fld id="{D723CA93-4BBF-43AB-A538-39903E4C269C}" type="datetimeFigureOut">
               <a:rPr lang="en-US" smtClean="0"/>
-              <a:t>4/18/2025</a:t>
+              <a:t>5/11/2025</a:t>
             </a:fld>
             <a:endParaRPr lang="en-US"/>
           </a:p>
@@ -2719,7 +2720,7 @@
           <a:p>
             <a:fld id="{D723CA93-4BBF-43AB-A538-39903E4C269C}" type="datetimeFigureOut">
               <a:rPr lang="en-US" smtClean="0"/>
-              <a:t>4/18/2025</a:t>
+              <a:t>5/11/2025</a:t>
             </a:fld>
             <a:endParaRPr lang="en-US"/>
           </a:p>
@@ -2960,7 +2961,7 @@
           <a:p>
             <a:fld id="{D723CA93-4BBF-43AB-A538-39903E4C269C}" type="datetimeFigureOut">
               <a:rPr lang="en-US" smtClean="0"/>
-              <a:t>4/18/2025</a:t>
+              <a:t>5/11/2025</a:t>
             </a:fld>
             <a:endParaRPr lang="en-US"/>
           </a:p>
@@ -6058,7 +6059,15 @@
             </a:pPr>
             <a:r>
               <a:rPr lang="en-US" b="1" dirty="0"/>
-              <a:t>City : text</a:t>
+              <a:t>City : select [dropdown all city in the </a:t>
+            </a:r>
+            <a:r>
+              <a:rPr lang="en-US" b="1" dirty="0" err="1"/>
+              <a:t>ph</a:t>
+            </a:r>
+            <a:r>
+              <a:rPr lang="en-US" b="1" dirty="0"/>
+              <a:t>]</a:t>
             </a:r>
           </a:p>
           <a:p>
@@ -6557,7 +6566,15 @@
             </a:pPr>
             <a:r>
               <a:rPr lang="en-US" b="1" dirty="0"/>
-              <a:t>City : text</a:t>
+              <a:t>City : select [dropdown all city in the </a:t>
+            </a:r>
+            <a:r>
+              <a:rPr lang="en-US" b="1" dirty="0" err="1"/>
+              <a:t>ph</a:t>
+            </a:r>
+            <a:r>
+              <a:rPr lang="en-US" b="1" dirty="0"/>
+              <a:t>]</a:t>
             </a:r>
           </a:p>
           <a:p>
@@ -6934,6 +6951,447 @@
           <a:p>
             <a:r>
               <a:rPr lang="en-US" sz="2000" b="1" dirty="0"/>
+              <a:t>adminCustomer.html</a:t>
+            </a:r>
+          </a:p>
+        </p:txBody>
+      </p:sp>
+      <p:sp>
+        <p:nvSpPr>
+          <p:cNvPr id="3" name="Rectangle: Rounded Corners 2">
+            <a:extLst>
+              <a:ext uri="{FF2B5EF4-FFF2-40B4-BE49-F238E27FC236}">
+                <a16:creationId xmlns:a16="http://schemas.microsoft.com/office/drawing/2014/main" id="{E84989AE-1420-7CFC-7A33-B4FACAA95828}"/>
+              </a:ext>
+            </a:extLst>
+          </p:cNvPr>
+          <p:cNvSpPr/>
+          <p:nvPr/>
+        </p:nvSpPr>
+        <p:spPr>
+          <a:xfrm>
+            <a:off x="112221" y="718993"/>
+            <a:ext cx="5374179" cy="4810414"/>
+          </a:xfrm>
+          <a:prstGeom prst="roundRect">
+            <a:avLst>
+              <a:gd name="adj" fmla="val 3063"/>
+            </a:avLst>
+          </a:prstGeom>
+          <a:solidFill>
+            <a:schemeClr val="accent6">
+              <a:lumMod val="50000"/>
+            </a:schemeClr>
+          </a:solidFill>
+          <a:ln>
+            <a:noFill/>
+          </a:ln>
+        </p:spPr>
+        <p:style>
+          <a:lnRef idx="2">
+            <a:schemeClr val="accent1">
+              <a:shade val="15000"/>
+            </a:schemeClr>
+          </a:lnRef>
+          <a:fillRef idx="1">
+            <a:schemeClr val="accent1"/>
+          </a:fillRef>
+          <a:effectRef idx="0">
+            <a:schemeClr val="accent1"/>
+          </a:effectRef>
+          <a:fontRef idx="minor">
+            <a:schemeClr val="lt1"/>
+          </a:fontRef>
+        </p:style>
+        <p:txBody>
+          <a:bodyPr rtlCol="0" anchor="ctr"/>
+          <a:lstStyle/>
+          <a:p>
+            <a:r>
+              <a:rPr lang="en-US" sz="2000" b="1" dirty="0"/>
+              <a:t>{</a:t>
+            </a:r>
+          </a:p>
+          <a:p>
+            <a:pPr marL="342900" indent="-342900">
+              <a:buFont typeface="Arial" panose="020B0604020202020204" pitchFamily="34" charset="0"/>
+              <a:buChar char="•"/>
+            </a:pPr>
+            <a:r>
+              <a:rPr lang="en-US" sz="2000" b="1" dirty="0"/>
+              <a:t>Search input</a:t>
+            </a:r>
+          </a:p>
+          <a:p>
+            <a:pPr marL="342900" indent="-342900">
+              <a:buFont typeface="Arial" panose="020B0604020202020204" pitchFamily="34" charset="0"/>
+              <a:buChar char="•"/>
+            </a:pPr>
+            <a:r>
+              <a:rPr lang="en-US" sz="2000" b="1" dirty="0"/>
+              <a:t>Search </a:t>
+            </a:r>
+            <a:r>
+              <a:rPr lang="en-US" sz="2000" b="1" dirty="0" err="1"/>
+              <a:t>btn</a:t>
+            </a:r>
+            <a:endParaRPr lang="en-US" sz="2000" b="1" dirty="0"/>
+          </a:p>
+          <a:p>
+            <a:r>
+              <a:rPr lang="en-US" sz="2000" b="1" dirty="0"/>
+              <a:t>}</a:t>
+            </a:r>
+          </a:p>
+          <a:p>
+            <a:endParaRPr lang="en-US" sz="2000" b="1" dirty="0"/>
+          </a:p>
+          <a:p>
+            <a:r>
+              <a:rPr lang="en-US" sz="2000" b="1" dirty="0"/>
+              <a:t>Customer Lists (Deactivated/Active toggle){</a:t>
+            </a:r>
+          </a:p>
+          <a:p>
+            <a:pPr marL="800100" lvl="1" indent="-342900">
+              <a:buFont typeface="Arial" panose="020B0604020202020204" pitchFamily="34" charset="0"/>
+              <a:buChar char="•"/>
+            </a:pPr>
+            <a:r>
+              <a:rPr lang="en-US" sz="2000" b="1" dirty="0"/>
+              <a:t>First, Last Name,</a:t>
+            </a:r>
+          </a:p>
+          <a:p>
+            <a:pPr marL="800100" lvl="1" indent="-342900">
+              <a:buFont typeface="Arial" panose="020B0604020202020204" pitchFamily="34" charset="0"/>
+              <a:buChar char="•"/>
+            </a:pPr>
+            <a:r>
+              <a:rPr lang="en-US" sz="2000" b="1" dirty="0"/>
+              <a:t>Email,</a:t>
+            </a:r>
+          </a:p>
+          <a:p>
+            <a:pPr marL="800100" lvl="1" indent="-342900">
+              <a:buFont typeface="Arial" panose="020B0604020202020204" pitchFamily="34" charset="0"/>
+              <a:buChar char="•"/>
+            </a:pPr>
+            <a:r>
+              <a:rPr lang="en-US" sz="2000" b="1" dirty="0"/>
+              <a:t>Violations: Integer{</a:t>
+            </a:r>
+          </a:p>
+          <a:p>
+            <a:pPr marL="1257300" lvl="2" indent="-342900">
+              <a:buFont typeface="Arial" panose="020B0604020202020204" pitchFamily="34" charset="0"/>
+              <a:buChar char="•"/>
+            </a:pPr>
+            <a:r>
+              <a:rPr lang="en-US" sz="2000" b="1" dirty="0"/>
+              <a:t>If more than 1 : color yellow</a:t>
+            </a:r>
+          </a:p>
+          <a:p>
+            <a:pPr marL="1257300" lvl="2" indent="-342900">
+              <a:buFont typeface="Arial" panose="020B0604020202020204" pitchFamily="34" charset="0"/>
+              <a:buChar char="•"/>
+            </a:pPr>
+            <a:r>
+              <a:rPr lang="en-US" sz="2000" b="1" dirty="0"/>
+              <a:t>If more than 3 : Red</a:t>
+            </a:r>
+          </a:p>
+          <a:p>
+            <a:pPr lvl="1"/>
+            <a:r>
+              <a:rPr lang="en-US" sz="2000" b="1" dirty="0"/>
+              <a:t>}</a:t>
+            </a:r>
+          </a:p>
+          <a:p>
+            <a:pPr marL="800100" lvl="1" indent="-342900">
+              <a:buFont typeface="Arial" panose="020B0604020202020204" pitchFamily="34" charset="0"/>
+              <a:buChar char="•"/>
+            </a:pPr>
+            <a:r>
+              <a:rPr lang="en-US" sz="2000" b="1" dirty="0" err="1"/>
+              <a:t>ViewViolationBtn</a:t>
+            </a:r>
+            <a:r>
+              <a:rPr lang="en-US" sz="2000" b="1" dirty="0"/>
+              <a:t> : modal</a:t>
+            </a:r>
+          </a:p>
+          <a:p>
+            <a:r>
+              <a:rPr lang="en-US" sz="2000" b="1" dirty="0"/>
+              <a:t>}</a:t>
+            </a:r>
+          </a:p>
+          <a:p>
+            <a:endParaRPr lang="en-US" sz="2000" b="1" dirty="0"/>
+          </a:p>
+        </p:txBody>
+      </p:sp>
+      <p:sp>
+        <p:nvSpPr>
+          <p:cNvPr id="2" name="Rectangle: Rounded Corners 1">
+            <a:extLst>
+              <a:ext uri="{FF2B5EF4-FFF2-40B4-BE49-F238E27FC236}">
+                <a16:creationId xmlns:a16="http://schemas.microsoft.com/office/drawing/2014/main" id="{53EECA4E-EA2E-8B17-6C2B-12466435E058}"/>
+              </a:ext>
+            </a:extLst>
+          </p:cNvPr>
+          <p:cNvSpPr/>
+          <p:nvPr/>
+        </p:nvSpPr>
+        <p:spPr>
+          <a:xfrm>
+            <a:off x="5917275" y="718993"/>
+            <a:ext cx="5374179" cy="4810414"/>
+          </a:xfrm>
+          <a:prstGeom prst="roundRect">
+            <a:avLst>
+              <a:gd name="adj" fmla="val 3063"/>
+            </a:avLst>
+          </a:prstGeom>
+          <a:solidFill>
+            <a:schemeClr val="accent6">
+              <a:lumMod val="50000"/>
+            </a:schemeClr>
+          </a:solidFill>
+          <a:ln>
+            <a:noFill/>
+          </a:ln>
+        </p:spPr>
+        <p:style>
+          <a:lnRef idx="2">
+            <a:schemeClr val="accent1">
+              <a:shade val="15000"/>
+            </a:schemeClr>
+          </a:lnRef>
+          <a:fillRef idx="1">
+            <a:schemeClr val="accent1"/>
+          </a:fillRef>
+          <a:effectRef idx="0">
+            <a:schemeClr val="accent1"/>
+          </a:effectRef>
+          <a:fontRef idx="minor">
+            <a:schemeClr val="lt1"/>
+          </a:fontRef>
+        </p:style>
+        <p:txBody>
+          <a:bodyPr rtlCol="0" anchor="ctr"/>
+          <a:lstStyle/>
+          <a:p>
+            <a:r>
+              <a:rPr lang="en-US" sz="2000" b="1" dirty="0"/>
+              <a:t>Modal{</a:t>
+            </a:r>
+          </a:p>
+          <a:p>
+            <a:pPr marL="800100" lvl="1" indent="-342900">
+              <a:buFont typeface="Arial" panose="020B0604020202020204" pitchFamily="34" charset="0"/>
+              <a:buChar char="•"/>
+            </a:pPr>
+            <a:r>
+              <a:rPr lang="en-US" sz="2000" b="1" dirty="0" err="1"/>
+              <a:t>DeactivateUserBtn</a:t>
+            </a:r>
+            <a:r>
+              <a:rPr lang="en-US" sz="2000" b="1" dirty="0"/>
+              <a:t> : “y/n”</a:t>
+            </a:r>
+          </a:p>
+          <a:p>
+            <a:r>
+              <a:rPr lang="en-US" sz="2000" b="1" dirty="0"/>
+              <a:t>// could be card or table</a:t>
+            </a:r>
+          </a:p>
+          <a:p>
+            <a:pPr marL="800100" lvl="1" indent="-342900">
+              <a:buFont typeface="Arial" panose="020B0604020202020204" pitchFamily="34" charset="0"/>
+              <a:buChar char="•"/>
+            </a:pPr>
+            <a:r>
+              <a:rPr lang="en-US" sz="2000" b="1" dirty="0" err="1"/>
+              <a:t>ListofViolation</a:t>
+            </a:r>
+            <a:r>
+              <a:rPr lang="en-US" sz="2000" b="1" dirty="0"/>
+              <a:t>{</a:t>
+            </a:r>
+          </a:p>
+          <a:p>
+            <a:pPr marL="1257300" lvl="2" indent="-342900">
+              <a:buFont typeface="Arial" panose="020B0604020202020204" pitchFamily="34" charset="0"/>
+              <a:buChar char="•"/>
+            </a:pPr>
+            <a:r>
+              <a:rPr lang="en-US" sz="2000" b="1" dirty="0"/>
+              <a:t>Reason</a:t>
+            </a:r>
+          </a:p>
+          <a:p>
+            <a:pPr marL="1257300" lvl="2" indent="-342900">
+              <a:buFont typeface="Arial" panose="020B0604020202020204" pitchFamily="34" charset="0"/>
+              <a:buChar char="•"/>
+            </a:pPr>
+            <a:r>
+              <a:rPr lang="en-US" sz="2000" b="1" dirty="0"/>
+              <a:t>Date</a:t>
+            </a:r>
+          </a:p>
+          <a:p>
+            <a:pPr marL="1257300" lvl="2" indent="-342900">
+              <a:buFont typeface="Arial" panose="020B0604020202020204" pitchFamily="34" charset="0"/>
+              <a:buChar char="•"/>
+            </a:pPr>
+            <a:r>
+              <a:rPr lang="en-US" sz="2000" b="1" dirty="0"/>
+              <a:t>Transaction #</a:t>
+            </a:r>
+          </a:p>
+          <a:p>
+            <a:pPr marL="1257300" lvl="2" indent="-342900">
+              <a:buFont typeface="Arial" panose="020B0604020202020204" pitchFamily="34" charset="0"/>
+              <a:buChar char="•"/>
+            </a:pPr>
+            <a:r>
+              <a:rPr lang="en-US" sz="2000" b="1" dirty="0" err="1"/>
+              <a:t>ReportedBy</a:t>
+            </a:r>
+            <a:endParaRPr lang="en-US" sz="2000" b="1" dirty="0"/>
+          </a:p>
+          <a:p>
+            <a:pPr lvl="1"/>
+            <a:r>
+              <a:rPr lang="en-US" sz="2000" b="1" dirty="0"/>
+              <a:t>}</a:t>
+            </a:r>
+          </a:p>
+          <a:p>
+            <a:r>
+              <a:rPr lang="en-US" sz="2000" b="1" dirty="0"/>
+              <a:t>}</a:t>
+            </a:r>
+          </a:p>
+          <a:p>
+            <a:endParaRPr lang="en-US" sz="2000" b="1" dirty="0"/>
+          </a:p>
+        </p:txBody>
+      </p:sp>
+      <p:cxnSp>
+        <p:nvCxnSpPr>
+          <p:cNvPr id="5" name="Connector: Curved 4">
+            <a:extLst>
+              <a:ext uri="{FF2B5EF4-FFF2-40B4-BE49-F238E27FC236}">
+                <a16:creationId xmlns:a16="http://schemas.microsoft.com/office/drawing/2014/main" id="{B79ECDB9-9D0A-5FF8-0777-A8B4A36186C3}"/>
+              </a:ext>
+            </a:extLst>
+          </p:cNvPr>
+          <p:cNvCxnSpPr>
+            <a:cxnSpLocks/>
+          </p:cNvCxnSpPr>
+          <p:nvPr/>
+        </p:nvCxnSpPr>
+        <p:spPr>
+          <a:xfrm rot="5400000">
+            <a:off x="3556002" y="2124365"/>
+            <a:ext cx="2964873" cy="2115125"/>
+          </a:xfrm>
+          <a:prstGeom prst="curvedConnector3">
+            <a:avLst>
+              <a:gd name="adj1" fmla="val 50000"/>
+            </a:avLst>
+          </a:prstGeom>
+          <a:ln w="19050" cap="flat" cmpd="sng" algn="ctr">
+            <a:solidFill>
+              <a:schemeClr val="accent4"/>
+            </a:solidFill>
+            <a:prstDash val="solid"/>
+            <a:round/>
+            <a:headEnd type="arrow" w="med" len="med"/>
+            <a:tailEnd type="arrow" w="med" len="med"/>
+          </a:ln>
+        </p:spPr>
+        <p:style>
+          <a:lnRef idx="0">
+            <a:scrgbClr r="0" g="0" b="0"/>
+          </a:lnRef>
+          <a:fillRef idx="0">
+            <a:scrgbClr r="0" g="0" b="0"/>
+          </a:fillRef>
+          <a:effectRef idx="0">
+            <a:scrgbClr r="0" g="0" b="0"/>
+          </a:effectRef>
+          <a:fontRef idx="minor">
+            <a:schemeClr val="tx1"/>
+          </a:fontRef>
+        </p:style>
+      </p:cxnSp>
+    </p:spTree>
+    <p:extLst>
+      <p:ext uri="{BB962C8B-B14F-4D97-AF65-F5344CB8AC3E}">
+        <p14:creationId xmlns:p14="http://schemas.microsoft.com/office/powerpoint/2010/main" val="3258476187"/>
+      </p:ext>
+    </p:extLst>
+  </p:cSld>
+  <p:clrMapOvr>
+    <a:masterClrMapping/>
+  </p:clrMapOvr>
+</p:sld>
+</file>
+
+<file path=ppt/slides/slide19.xml><?xml version="1.0" encoding="utf-8"?>
+<p:sld xmlns:a="http://schemas.openxmlformats.org/drawingml/2006/main" xmlns:r="http://schemas.openxmlformats.org/officeDocument/2006/relationships" xmlns:p="http://schemas.openxmlformats.org/presentationml/2006/main">
+  <p:cSld>
+    <p:spTree>
+      <p:nvGrpSpPr>
+        <p:cNvPr id="1" name=""/>
+        <p:cNvGrpSpPr/>
+        <p:nvPr/>
+      </p:nvGrpSpPr>
+      <p:grpSpPr>
+        <a:xfrm>
+          <a:off x="0" y="0"/>
+          <a:ext cx="0" cy="0"/>
+          <a:chOff x="0" y="0"/>
+          <a:chExt cx="0" cy="0"/>
+        </a:xfrm>
+      </p:grpSpPr>
+      <p:sp>
+        <p:nvSpPr>
+          <p:cNvPr id="4" name="TextBox 3">
+            <a:extLst>
+              <a:ext uri="{FF2B5EF4-FFF2-40B4-BE49-F238E27FC236}">
+                <a16:creationId xmlns:a16="http://schemas.microsoft.com/office/drawing/2014/main" id="{E094F53A-6361-E94E-5BDE-6B5297C1498E}"/>
+              </a:ext>
+            </a:extLst>
+          </p:cNvPr>
+          <p:cNvSpPr txBox="1"/>
+          <p:nvPr/>
+        </p:nvSpPr>
+        <p:spPr>
+          <a:xfrm>
+            <a:off x="-1" y="0"/>
+            <a:ext cx="3519055" cy="400110"/>
+          </a:xfrm>
+          <a:prstGeom prst="rect">
+            <a:avLst/>
+          </a:prstGeom>
+          <a:noFill/>
+        </p:spPr>
+        <p:txBody>
+          <a:bodyPr wrap="square" rtlCol="0">
+            <a:spAutoFit/>
+          </a:bodyPr>
+          <a:lstStyle/>
+          <a:p>
+            <a:r>
+              <a:rPr lang="en-US" sz="2000" b="1" dirty="0"/>
               <a:t>adminEmpoyee.html</a:t>
             </a:r>
           </a:p>
@@ -7126,7 +7584,129 @@
 </p:sld>
 </file>
 
-<file path=ppt/slides/slide19.xml><?xml version="1.0" encoding="utf-8"?>
+<file path=ppt/slides/slide2.xml><?xml version="1.0" encoding="utf-8"?>
+<p:sld xmlns:a="http://schemas.openxmlformats.org/drawingml/2006/main" xmlns:r="http://schemas.openxmlformats.org/officeDocument/2006/relationships" xmlns:p="http://schemas.openxmlformats.org/presentationml/2006/main">
+  <p:cSld>
+    <p:spTree>
+      <p:nvGrpSpPr>
+        <p:cNvPr id="1" name=""/>
+        <p:cNvGrpSpPr/>
+        <p:nvPr/>
+      </p:nvGrpSpPr>
+      <p:grpSpPr>
+        <a:xfrm>
+          <a:off x="0" y="0"/>
+          <a:ext cx="0" cy="0"/>
+          <a:chOff x="0" y="0"/>
+          <a:chExt cx="0" cy="0"/>
+        </a:xfrm>
+      </p:grpSpPr>
+      <p:pic>
+        <p:nvPicPr>
+          <p:cNvPr id="5" name="Picture 4" descr="A screen shot of a computer program&#10;&#10;AI-generated content may be incorrect.">
+            <a:extLst>
+              <a:ext uri="{FF2B5EF4-FFF2-40B4-BE49-F238E27FC236}">
+                <a16:creationId xmlns:a16="http://schemas.microsoft.com/office/drawing/2014/main" id="{1485D8FE-FA3B-F048-2D95-8FE5EBFD1521}"/>
+              </a:ext>
+            </a:extLst>
+          </p:cNvPr>
+          <p:cNvPicPr>
+            <a:picLocks noChangeAspect="1"/>
+          </p:cNvPicPr>
+          <p:nvPr/>
+        </p:nvPicPr>
+        <p:blipFill>
+          <a:blip r:embed="rId2">
+            <a:extLst>
+              <a:ext uri="{28A0092B-C50C-407E-A947-70E740481C1C}">
+                <a14:useLocalDpi xmlns:a14="http://schemas.microsoft.com/office/drawing/2010/main" val="0"/>
+              </a:ext>
+            </a:extLst>
+          </a:blip>
+          <a:stretch>
+            <a:fillRect/>
+          </a:stretch>
+        </p:blipFill>
+        <p:spPr>
+          <a:xfrm>
+            <a:off x="-457200" y="-285652"/>
+            <a:ext cx="12856069" cy="7576837"/>
+          </a:xfrm>
+          <a:prstGeom prst="rect">
+            <a:avLst/>
+          </a:prstGeom>
+        </p:spPr>
+      </p:pic>
+      <p:sp>
+        <p:nvSpPr>
+          <p:cNvPr id="2" name="TextBox 1">
+            <a:extLst>
+              <a:ext uri="{FF2B5EF4-FFF2-40B4-BE49-F238E27FC236}">
+                <a16:creationId xmlns:a16="http://schemas.microsoft.com/office/drawing/2014/main" id="{D7905721-4A05-C1B3-9952-8B578834C87C}"/>
+              </a:ext>
+            </a:extLst>
+          </p:cNvPr>
+          <p:cNvSpPr txBox="1"/>
+          <p:nvPr/>
+        </p:nvSpPr>
+        <p:spPr>
+          <a:xfrm>
+            <a:off x="4679605" y="1057380"/>
+            <a:ext cx="6638174" cy="1938992"/>
+          </a:xfrm>
+          <a:prstGeom prst="rect">
+            <a:avLst/>
+          </a:prstGeom>
+          <a:noFill/>
+        </p:spPr>
+        <p:txBody>
+          <a:bodyPr wrap="square" rtlCol="0">
+            <a:spAutoFit/>
+          </a:bodyPr>
+          <a:lstStyle/>
+          <a:p>
+            <a:pPr algn="ctr"/>
+            <a:r>
+              <a:rPr lang="en-US" sz="4000" b="1" dirty="0">
+                <a:solidFill>
+                  <a:schemeClr val="bg1"/>
+                </a:solidFill>
+              </a:rPr>
+              <a:t>All the color palettes are stored in </a:t>
+            </a:r>
+            <a:r>
+              <a:rPr lang="en-US" sz="4000" b="1" dirty="0">
+                <a:solidFill>
+                  <a:srgbClr val="FF0000"/>
+                </a:solidFill>
+              </a:rPr>
+              <a:t>CSS variables </a:t>
+            </a:r>
+            <a:r>
+              <a:rPr lang="en-US" sz="4000" b="1" dirty="0">
+                <a:solidFill>
+                  <a:schemeClr val="bg1"/>
+                </a:solidFill>
+              </a:rPr>
+              <a:t>to toggle dark/light mode</a:t>
+            </a:r>
+          </a:p>
+        </p:txBody>
+      </p:sp>
+    </p:spTree>
+    <p:extLst>
+      <p:ext uri="{BB962C8B-B14F-4D97-AF65-F5344CB8AC3E}">
+        <p14:creationId xmlns:p14="http://schemas.microsoft.com/office/powerpoint/2010/main" val="3537636929"/>
+      </p:ext>
+    </p:extLst>
+  </p:cSld>
+  <p:clrMapOvr>
+    <a:masterClrMapping/>
+  </p:clrMapOvr>
+</p:sld>
+</file>
+
+<file path=ppt/slides/slide20.xml><?xml version="1.0" encoding="utf-8"?>
 <p:sld xmlns:a="http://schemas.openxmlformats.org/drawingml/2006/main" xmlns:r="http://schemas.openxmlformats.org/officeDocument/2006/relationships" xmlns:p="http://schemas.openxmlformats.org/presentationml/2006/main">
   <p:cSld>
     <p:spTree>
@@ -7321,129 +7901,7 @@
 </p:sld>
 </file>
 
-<file path=ppt/slides/slide2.xml><?xml version="1.0" encoding="utf-8"?>
-<p:sld xmlns:a="http://schemas.openxmlformats.org/drawingml/2006/main" xmlns:r="http://schemas.openxmlformats.org/officeDocument/2006/relationships" xmlns:p="http://schemas.openxmlformats.org/presentationml/2006/main">
-  <p:cSld>
-    <p:spTree>
-      <p:nvGrpSpPr>
-        <p:cNvPr id="1" name=""/>
-        <p:cNvGrpSpPr/>
-        <p:nvPr/>
-      </p:nvGrpSpPr>
-      <p:grpSpPr>
-        <a:xfrm>
-          <a:off x="0" y="0"/>
-          <a:ext cx="0" cy="0"/>
-          <a:chOff x="0" y="0"/>
-          <a:chExt cx="0" cy="0"/>
-        </a:xfrm>
-      </p:grpSpPr>
-      <p:pic>
-        <p:nvPicPr>
-          <p:cNvPr id="5" name="Picture 4" descr="A screen shot of a computer program&#10;&#10;AI-generated content may be incorrect.">
-            <a:extLst>
-              <a:ext uri="{FF2B5EF4-FFF2-40B4-BE49-F238E27FC236}">
-                <a16:creationId xmlns:a16="http://schemas.microsoft.com/office/drawing/2014/main" id="{1485D8FE-FA3B-F048-2D95-8FE5EBFD1521}"/>
-              </a:ext>
-            </a:extLst>
-          </p:cNvPr>
-          <p:cNvPicPr>
-            <a:picLocks noChangeAspect="1"/>
-          </p:cNvPicPr>
-          <p:nvPr/>
-        </p:nvPicPr>
-        <p:blipFill>
-          <a:blip r:embed="rId2">
-            <a:extLst>
-              <a:ext uri="{28A0092B-C50C-407E-A947-70E740481C1C}">
-                <a14:useLocalDpi xmlns:a14="http://schemas.microsoft.com/office/drawing/2010/main" val="0"/>
-              </a:ext>
-            </a:extLst>
-          </a:blip>
-          <a:stretch>
-            <a:fillRect/>
-          </a:stretch>
-        </p:blipFill>
-        <p:spPr>
-          <a:xfrm>
-            <a:off x="-457200" y="-285652"/>
-            <a:ext cx="12856069" cy="7576837"/>
-          </a:xfrm>
-          <a:prstGeom prst="rect">
-            <a:avLst/>
-          </a:prstGeom>
-        </p:spPr>
-      </p:pic>
-      <p:sp>
-        <p:nvSpPr>
-          <p:cNvPr id="2" name="TextBox 1">
-            <a:extLst>
-              <a:ext uri="{FF2B5EF4-FFF2-40B4-BE49-F238E27FC236}">
-                <a16:creationId xmlns:a16="http://schemas.microsoft.com/office/drawing/2014/main" id="{D7905721-4A05-C1B3-9952-8B578834C87C}"/>
-              </a:ext>
-            </a:extLst>
-          </p:cNvPr>
-          <p:cNvSpPr txBox="1"/>
-          <p:nvPr/>
-        </p:nvSpPr>
-        <p:spPr>
-          <a:xfrm>
-            <a:off x="4679605" y="1057380"/>
-            <a:ext cx="6638174" cy="1938992"/>
-          </a:xfrm>
-          <a:prstGeom prst="rect">
-            <a:avLst/>
-          </a:prstGeom>
-          <a:noFill/>
-        </p:spPr>
-        <p:txBody>
-          <a:bodyPr wrap="square" rtlCol="0">
-            <a:spAutoFit/>
-          </a:bodyPr>
-          <a:lstStyle/>
-          <a:p>
-            <a:pPr algn="ctr"/>
-            <a:r>
-              <a:rPr lang="en-US" sz="4000" b="1" dirty="0">
-                <a:solidFill>
-                  <a:schemeClr val="bg1"/>
-                </a:solidFill>
-              </a:rPr>
-              <a:t>All the color palettes are stored in </a:t>
-            </a:r>
-            <a:r>
-              <a:rPr lang="en-US" sz="4000" b="1" dirty="0">
-                <a:solidFill>
-                  <a:srgbClr val="FF0000"/>
-                </a:solidFill>
-              </a:rPr>
-              <a:t>CSS variables </a:t>
-            </a:r>
-            <a:r>
-              <a:rPr lang="en-US" sz="4000" b="1" dirty="0">
-                <a:solidFill>
-                  <a:schemeClr val="bg1"/>
-                </a:solidFill>
-              </a:rPr>
-              <a:t>to toggle dark/light mode</a:t>
-            </a:r>
-          </a:p>
-        </p:txBody>
-      </p:sp>
-    </p:spTree>
-    <p:extLst>
-      <p:ext uri="{BB962C8B-B14F-4D97-AF65-F5344CB8AC3E}">
-        <p14:creationId xmlns:p14="http://schemas.microsoft.com/office/powerpoint/2010/main" val="3537636929"/>
-      </p:ext>
-    </p:extLst>
-  </p:cSld>
-  <p:clrMapOvr>
-    <a:masterClrMapping/>
-  </p:clrMapOvr>
-</p:sld>
-</file>
-
-<file path=ppt/slides/slide20.xml><?xml version="1.0" encoding="utf-8"?>
+<file path=ppt/slides/slide21.xml><?xml version="1.0" encoding="utf-8"?>
 <p:sld xmlns:a="http://schemas.openxmlformats.org/drawingml/2006/main" xmlns:r="http://schemas.openxmlformats.org/officeDocument/2006/relationships" xmlns:p="http://schemas.openxmlformats.org/presentationml/2006/main">
   <p:cSld>
     <p:spTree>
@@ -7670,7 +8128,7 @@
 </p:sld>
 </file>
 
-<file path=ppt/slides/slide21.xml><?xml version="1.0" encoding="utf-8"?>
+<file path=ppt/slides/slide22.xml><?xml version="1.0" encoding="utf-8"?>
 <p:sld xmlns:a="http://schemas.openxmlformats.org/drawingml/2006/main" xmlns:r="http://schemas.openxmlformats.org/officeDocument/2006/relationships" xmlns:p="http://schemas.openxmlformats.org/presentationml/2006/main">
   <p:cSld>
     <p:spTree>
@@ -7926,7 +8384,7 @@
 </p:sld>
 </file>
 
-<file path=ppt/slides/slide22.xml><?xml version="1.0" encoding="utf-8"?>
+<file path=ppt/slides/slide23.xml><?xml version="1.0" encoding="utf-8"?>
 <p:sld xmlns:a="http://schemas.openxmlformats.org/drawingml/2006/main" xmlns:r="http://schemas.openxmlformats.org/officeDocument/2006/relationships" xmlns:p="http://schemas.openxmlformats.org/presentationml/2006/main">
   <p:cSld>
     <p:spTree>
@@ -8182,7 +8640,7 @@
 </p:sld>
 </file>
 
-<file path=ppt/slides/slide23.xml><?xml version="1.0" encoding="utf-8"?>
+<file path=ppt/slides/slide24.xml><?xml version="1.0" encoding="utf-8"?>
 <p:sld xmlns:a="http://schemas.openxmlformats.org/drawingml/2006/main" xmlns:r="http://schemas.openxmlformats.org/officeDocument/2006/relationships" xmlns:p="http://schemas.openxmlformats.org/presentationml/2006/main">
   <p:cSld>
     <p:spTree>
@@ -8379,7 +8837,7 @@
 </p:sld>
 </file>
 
-<file path=ppt/slides/slide24.xml><?xml version="1.0" encoding="utf-8"?>
+<file path=ppt/slides/slide25.xml><?xml version="1.0" encoding="utf-8"?>
 <p:sld xmlns:a="http://schemas.openxmlformats.org/drawingml/2006/main" xmlns:r="http://schemas.openxmlformats.org/officeDocument/2006/relationships" xmlns:p="http://schemas.openxmlformats.org/presentationml/2006/main">
   <p:cSld>
     <p:spTree>
@@ -8549,7 +9007,7 @@
 </p:sld>
 </file>
 
-<file path=ppt/slides/slide25.xml><?xml version="1.0" encoding="utf-8"?>
+<file path=ppt/slides/slide26.xml><?xml version="1.0" encoding="utf-8"?>
 <p:sld xmlns:a="http://schemas.openxmlformats.org/drawingml/2006/main" xmlns:r="http://schemas.openxmlformats.org/officeDocument/2006/relationships" xmlns:p="http://schemas.openxmlformats.org/presentationml/2006/main">
   <p:cSld>
     <p:spTree>
@@ -8763,7 +9221,7 @@
 </p:sld>
 </file>
 
-<file path=ppt/slides/slide26.xml><?xml version="1.0" encoding="utf-8"?>
+<file path=ppt/slides/slide27.xml><?xml version="1.0" encoding="utf-8"?>
 <p:sld xmlns:a="http://schemas.openxmlformats.org/drawingml/2006/main" xmlns:r="http://schemas.openxmlformats.org/officeDocument/2006/relationships" xmlns:p="http://schemas.openxmlformats.org/presentationml/2006/main">
   <p:cSld>
     <p:spTree>
@@ -8977,7 +9435,7 @@
 </p:sld>
 </file>
 
-<file path=ppt/slides/slide27.xml><?xml version="1.0" encoding="utf-8"?>
+<file path=ppt/slides/slide28.xml><?xml version="1.0" encoding="utf-8"?>
 <p:sld xmlns:a="http://schemas.openxmlformats.org/drawingml/2006/main" xmlns:r="http://schemas.openxmlformats.org/officeDocument/2006/relationships" xmlns:p="http://schemas.openxmlformats.org/presentationml/2006/main">
   <p:cSld>
     <p:spTree>
@@ -9463,7 +9921,7 @@
 </p:sld>
 </file>
 
-<file path=ppt/slides/slide28.xml><?xml version="1.0" encoding="utf-8"?>
+<file path=ppt/slides/slide29.xml><?xml version="1.0" encoding="utf-8"?>
 <p:sld xmlns:a="http://schemas.openxmlformats.org/drawingml/2006/main" xmlns:r="http://schemas.openxmlformats.org/officeDocument/2006/relationships" xmlns:p="http://schemas.openxmlformats.org/presentationml/2006/main">
   <p:cSld>
     <p:spTree>
@@ -9949,7 +10407,78 @@
 </p:sld>
 </file>
 
-<file path=ppt/slides/slide29.xml><?xml version="1.0" encoding="utf-8"?>
+<file path=ppt/slides/slide3.xml><?xml version="1.0" encoding="utf-8"?>
+<p:sld xmlns:a="http://schemas.openxmlformats.org/drawingml/2006/main" xmlns:r="http://schemas.openxmlformats.org/officeDocument/2006/relationships" xmlns:p="http://schemas.openxmlformats.org/presentationml/2006/main">
+  <p:cSld>
+    <p:spTree>
+      <p:nvGrpSpPr>
+        <p:cNvPr id="1" name=""/>
+        <p:cNvGrpSpPr/>
+        <p:nvPr/>
+      </p:nvGrpSpPr>
+      <p:grpSpPr>
+        <a:xfrm>
+          <a:off x="0" y="0"/>
+          <a:ext cx="0" cy="0"/>
+          <a:chOff x="0" y="0"/>
+          <a:chExt cx="0" cy="0"/>
+        </a:xfrm>
+      </p:grpSpPr>
+      <p:sp>
+        <p:nvSpPr>
+          <p:cNvPr id="2" name="TextBox 1">
+            <a:extLst>
+              <a:ext uri="{FF2B5EF4-FFF2-40B4-BE49-F238E27FC236}">
+                <a16:creationId xmlns:a16="http://schemas.microsoft.com/office/drawing/2014/main" id="{D7905721-4A05-C1B3-9952-8B578834C87C}"/>
+              </a:ext>
+            </a:extLst>
+          </p:cNvPr>
+          <p:cNvSpPr txBox="1"/>
+          <p:nvPr/>
+        </p:nvSpPr>
+        <p:spPr>
+          <a:xfrm>
+            <a:off x="2085802" y="2767280"/>
+            <a:ext cx="8020395" cy="1323439"/>
+          </a:xfrm>
+          <a:prstGeom prst="rect">
+            <a:avLst/>
+          </a:prstGeom>
+          <a:noFill/>
+        </p:spPr>
+        <p:txBody>
+          <a:bodyPr wrap="square" rtlCol="0">
+            <a:spAutoFit/>
+          </a:bodyPr>
+          <a:lstStyle/>
+          <a:p>
+            <a:pPr algn="ctr"/>
+            <a:r>
+              <a:rPr lang="en-US" sz="4000" b="1" dirty="0"/>
+              <a:t>Reusable Modal message in JS. Using  </a:t>
+            </a:r>
+            <a:r>
+              <a:rPr lang="en-US" sz="4000" b="1" dirty="0" err="1"/>
+              <a:t>document.createElement</a:t>
+            </a:r>
+            <a:endParaRPr lang="en-US" sz="4000" b="1" dirty="0"/>
+          </a:p>
+        </p:txBody>
+      </p:sp>
+    </p:spTree>
+    <p:extLst>
+      <p:ext uri="{BB962C8B-B14F-4D97-AF65-F5344CB8AC3E}">
+        <p14:creationId xmlns:p14="http://schemas.microsoft.com/office/powerpoint/2010/main" val="2959178089"/>
+      </p:ext>
+    </p:extLst>
+  </p:cSld>
+  <p:clrMapOvr>
+    <a:masterClrMapping/>
+  </p:clrMapOvr>
+</p:sld>
+</file>
+
+<file path=ppt/slides/slide30.xml><?xml version="1.0" encoding="utf-8"?>
 <p:sld xmlns:a="http://schemas.openxmlformats.org/drawingml/2006/main" xmlns:r="http://schemas.openxmlformats.org/officeDocument/2006/relationships" xmlns:p="http://schemas.openxmlformats.org/presentationml/2006/main">
   <p:cSld>
     <p:spTree>
@@ -10391,78 +10920,7 @@
 </p:sld>
 </file>
 
-<file path=ppt/slides/slide3.xml><?xml version="1.0" encoding="utf-8"?>
-<p:sld xmlns:a="http://schemas.openxmlformats.org/drawingml/2006/main" xmlns:r="http://schemas.openxmlformats.org/officeDocument/2006/relationships" xmlns:p="http://schemas.openxmlformats.org/presentationml/2006/main">
-  <p:cSld>
-    <p:spTree>
-      <p:nvGrpSpPr>
-        <p:cNvPr id="1" name=""/>
-        <p:cNvGrpSpPr/>
-        <p:nvPr/>
-      </p:nvGrpSpPr>
-      <p:grpSpPr>
-        <a:xfrm>
-          <a:off x="0" y="0"/>
-          <a:ext cx="0" cy="0"/>
-          <a:chOff x="0" y="0"/>
-          <a:chExt cx="0" cy="0"/>
-        </a:xfrm>
-      </p:grpSpPr>
-      <p:sp>
-        <p:nvSpPr>
-          <p:cNvPr id="2" name="TextBox 1">
-            <a:extLst>
-              <a:ext uri="{FF2B5EF4-FFF2-40B4-BE49-F238E27FC236}">
-                <a16:creationId xmlns:a16="http://schemas.microsoft.com/office/drawing/2014/main" id="{D7905721-4A05-C1B3-9952-8B578834C87C}"/>
-              </a:ext>
-            </a:extLst>
-          </p:cNvPr>
-          <p:cNvSpPr txBox="1"/>
-          <p:nvPr/>
-        </p:nvSpPr>
-        <p:spPr>
-          <a:xfrm>
-            <a:off x="2085802" y="2767280"/>
-            <a:ext cx="8020395" cy="1323439"/>
-          </a:xfrm>
-          <a:prstGeom prst="rect">
-            <a:avLst/>
-          </a:prstGeom>
-          <a:noFill/>
-        </p:spPr>
-        <p:txBody>
-          <a:bodyPr wrap="square" rtlCol="0">
-            <a:spAutoFit/>
-          </a:bodyPr>
-          <a:lstStyle/>
-          <a:p>
-            <a:pPr algn="ctr"/>
-            <a:r>
-              <a:rPr lang="en-US" sz="4000" b="1" dirty="0"/>
-              <a:t>Reusable Modal message in JS. Using  </a:t>
-            </a:r>
-            <a:r>
-              <a:rPr lang="en-US" sz="4000" b="1" dirty="0" err="1"/>
-              <a:t>document.createElement</a:t>
-            </a:r>
-            <a:endParaRPr lang="en-US" sz="4000" b="1" dirty="0"/>
-          </a:p>
-        </p:txBody>
-      </p:sp>
-    </p:spTree>
-    <p:extLst>
-      <p:ext uri="{BB962C8B-B14F-4D97-AF65-F5344CB8AC3E}">
-        <p14:creationId xmlns:p14="http://schemas.microsoft.com/office/powerpoint/2010/main" val="2959178089"/>
-      </p:ext>
-    </p:extLst>
-  </p:cSld>
-  <p:clrMapOvr>
-    <a:masterClrMapping/>
-  </p:clrMapOvr>
-</p:sld>
-</file>
-
-<file path=ppt/slides/slide30.xml><?xml version="1.0" encoding="utf-8"?>
+<file path=ppt/slides/slide31.xml><?xml version="1.0" encoding="utf-8"?>
 <p:sld xmlns:a="http://schemas.openxmlformats.org/drawingml/2006/main" xmlns:r="http://schemas.openxmlformats.org/officeDocument/2006/relationships" xmlns:p="http://schemas.openxmlformats.org/presentationml/2006/main">
   <p:cSld>
     <p:spTree>
@@ -10616,7 +11074,7 @@
 </p:sld>
 </file>
 
-<file path=ppt/slides/slide31.xml><?xml version="1.0" encoding="utf-8"?>
+<file path=ppt/slides/slide32.xml><?xml version="1.0" encoding="utf-8"?>
 <p:sld xmlns:a="http://schemas.openxmlformats.org/drawingml/2006/main" xmlns:r="http://schemas.openxmlformats.org/officeDocument/2006/relationships" xmlns:p="http://schemas.openxmlformats.org/presentationml/2006/main">
   <p:cSld>
     <p:spTree>
@@ -10682,7 +11140,7 @@
 </p:sld>
 </file>
 
-<file path=ppt/slides/slide32.xml><?xml version="1.0" encoding="utf-8"?>
+<file path=ppt/slides/slide33.xml><?xml version="1.0" encoding="utf-8"?>
 <p:sld xmlns:a="http://schemas.openxmlformats.org/drawingml/2006/main" xmlns:r="http://schemas.openxmlformats.org/officeDocument/2006/relationships" xmlns:p="http://schemas.openxmlformats.org/presentationml/2006/main">
   <p:cSld>
     <p:spTree>
@@ -10718,7 +11176,7 @@
           </a:xfrm>
           <a:prstGeom prst="roundRect">
             <a:avLst>
-              <a:gd name="adj" fmla="val 10428"/>
+              <a:gd name="adj" fmla="val 5607"/>
             </a:avLst>
           </a:prstGeom>
           <a:solidFill>
@@ -11164,7 +11622,7 @@
 </p:sld>
 </file>
 
-<file path=ppt/slides/slide33.xml><?xml version="1.0" encoding="utf-8"?>
+<file path=ppt/slides/slide34.xml><?xml version="1.0" encoding="utf-8"?>
 <p:sld xmlns:a="http://schemas.openxmlformats.org/drawingml/2006/main" xmlns:r="http://schemas.openxmlformats.org/officeDocument/2006/relationships" xmlns:p="http://schemas.openxmlformats.org/presentationml/2006/main">
   <p:cSld>
     <p:spTree>
@@ -11783,7 +12241,7 @@
 </p:sld>
 </file>
 
-<file path=ppt/slides/slide34.xml><?xml version="1.0" encoding="utf-8"?>
+<file path=ppt/slides/slide35.xml><?xml version="1.0" encoding="utf-8"?>
 <p:sld xmlns:a="http://schemas.openxmlformats.org/drawingml/2006/main" xmlns:r="http://schemas.openxmlformats.org/officeDocument/2006/relationships" xmlns:p="http://schemas.openxmlformats.org/presentationml/2006/main">
   <p:cSld>
     <p:spTree>
@@ -11962,7 +12420,7 @@
 </p:sld>
 </file>
 
-<file path=ppt/slides/slide35.xml><?xml version="1.0" encoding="utf-8"?>
+<file path=ppt/slides/slide36.xml><?xml version="1.0" encoding="utf-8"?>
 <p:sld xmlns:a="http://schemas.openxmlformats.org/drawingml/2006/main" xmlns:r="http://schemas.openxmlformats.org/officeDocument/2006/relationships" xmlns:p="http://schemas.openxmlformats.org/presentationml/2006/main">
   <p:cSld>
     <p:spTree>
@@ -12148,7 +12606,7 @@
 </p:sld>
 </file>
 
-<file path=ppt/slides/slide36.xml><?xml version="1.0" encoding="utf-8"?>
+<file path=ppt/slides/slide37.xml><?xml version="1.0" encoding="utf-8"?>
 <p:sld xmlns:a="http://schemas.openxmlformats.org/drawingml/2006/main" xmlns:r="http://schemas.openxmlformats.org/officeDocument/2006/relationships" xmlns:p="http://schemas.openxmlformats.org/presentationml/2006/main">
   <p:cSld>
     <p:spTree>
@@ -12498,7 +12956,7 @@
 </p:sld>
 </file>
 
-<file path=ppt/slides/slide37.xml><?xml version="1.0" encoding="utf-8"?>
+<file path=ppt/slides/slide38.xml><?xml version="1.0" encoding="utf-8"?>
 <p:sld xmlns:a="http://schemas.openxmlformats.org/drawingml/2006/main" xmlns:r="http://schemas.openxmlformats.org/officeDocument/2006/relationships" xmlns:p="http://schemas.openxmlformats.org/presentationml/2006/main">
   <p:cSld>
     <p:spTree>
@@ -12637,7 +13095,7 @@
 </p:sld>
 </file>
 
-<file path=ppt/slides/slide38.xml><?xml version="1.0" encoding="utf-8"?>
+<file path=ppt/slides/slide39.xml><?xml version="1.0" encoding="utf-8"?>
 <p:sld xmlns:a="http://schemas.openxmlformats.org/drawingml/2006/main" xmlns:r="http://schemas.openxmlformats.org/officeDocument/2006/relationships" xmlns:p="http://schemas.openxmlformats.org/presentationml/2006/main">
   <p:cSld>
     <p:spTree>
@@ -12703,7 +13161,7 @@
         </p:nvSpPr>
         <p:spPr>
           <a:xfrm>
-            <a:off x="3057236" y="2012722"/>
+            <a:off x="277090" y="2012722"/>
             <a:ext cx="6077528" cy="2832556"/>
           </a:xfrm>
           <a:prstGeom prst="roundRect">
@@ -12821,6 +13279,151 @@
           </a:p>
         </p:txBody>
       </p:sp>
+      <p:sp>
+        <p:nvSpPr>
+          <p:cNvPr id="2" name="Rectangle: Rounded Corners 1">
+            <a:extLst>
+              <a:ext uri="{FF2B5EF4-FFF2-40B4-BE49-F238E27FC236}">
+                <a16:creationId xmlns:a16="http://schemas.microsoft.com/office/drawing/2014/main" id="{5A4456B4-4281-F7F5-962D-D430BDB4B876}"/>
+              </a:ext>
+            </a:extLst>
+          </p:cNvPr>
+          <p:cNvSpPr/>
+          <p:nvPr/>
+        </p:nvSpPr>
+        <p:spPr>
+          <a:xfrm>
+            <a:off x="6890329" y="2012722"/>
+            <a:ext cx="4858326" cy="2832556"/>
+          </a:xfrm>
+          <a:prstGeom prst="roundRect">
+            <a:avLst>
+              <a:gd name="adj" fmla="val 5218"/>
+            </a:avLst>
+          </a:prstGeom>
+          <a:solidFill>
+            <a:schemeClr val="accent6">
+              <a:lumMod val="50000"/>
+            </a:schemeClr>
+          </a:solidFill>
+          <a:ln>
+            <a:noFill/>
+          </a:ln>
+        </p:spPr>
+        <p:style>
+          <a:lnRef idx="2">
+            <a:schemeClr val="accent1">
+              <a:shade val="15000"/>
+            </a:schemeClr>
+          </a:lnRef>
+          <a:fillRef idx="1">
+            <a:schemeClr val="accent1"/>
+          </a:fillRef>
+          <a:effectRef idx="0">
+            <a:schemeClr val="accent1"/>
+          </a:effectRef>
+          <a:fontRef idx="minor">
+            <a:schemeClr val="lt1"/>
+          </a:fontRef>
+        </p:style>
+        <p:txBody>
+          <a:bodyPr rtlCol="0" anchor="ctr"/>
+          <a:lstStyle/>
+          <a:p>
+            <a:r>
+              <a:rPr lang="en-US" b="1" dirty="0"/>
+              <a:t>Confirm Payment{</a:t>
+            </a:r>
+          </a:p>
+          <a:p>
+            <a:pPr marL="742950" lvl="1" indent="-285750">
+              <a:buFont typeface="Arial" panose="020B0604020202020204" pitchFamily="34" charset="0"/>
+              <a:buChar char="•"/>
+            </a:pPr>
+            <a:r>
+              <a:rPr lang="en-US" b="1" dirty="0"/>
+              <a:t>For: Reservation/Full Payment</a:t>
+            </a:r>
+          </a:p>
+          <a:p>
+            <a:pPr marL="742950" lvl="1" indent="-285750">
+              <a:buFont typeface="Arial" panose="020B0604020202020204" pitchFamily="34" charset="0"/>
+              <a:buChar char="•"/>
+            </a:pPr>
+            <a:r>
+              <a:rPr lang="en-US" b="1" dirty="0"/>
+              <a:t>Mode of Payment (</a:t>
+            </a:r>
+            <a:r>
+              <a:rPr lang="en-US" b="1" dirty="0" err="1"/>
+              <a:t>Gcash</a:t>
+            </a:r>
+            <a:r>
+              <a:rPr lang="en-US" b="1" dirty="0"/>
+              <a:t>, </a:t>
+            </a:r>
+            <a:r>
+              <a:rPr lang="en-US" b="1" dirty="0" err="1"/>
+              <a:t>Gotyme</a:t>
+            </a:r>
+            <a:r>
+              <a:rPr lang="en-US" b="1" dirty="0"/>
+              <a:t>, maya, </a:t>
+            </a:r>
+            <a:r>
+              <a:rPr lang="en-US" b="1" dirty="0" err="1"/>
+              <a:t>UnionBank</a:t>
+            </a:r>
+            <a:r>
+              <a:rPr lang="en-US" b="1" dirty="0"/>
+              <a:t>)</a:t>
+            </a:r>
+          </a:p>
+          <a:p>
+            <a:pPr marL="742950" lvl="1" indent="-285750">
+              <a:buFont typeface="Arial" panose="020B0604020202020204" pitchFamily="34" charset="0"/>
+              <a:buChar char="•"/>
+            </a:pPr>
+            <a:r>
+              <a:rPr lang="en-US" b="1" dirty="0"/>
+              <a:t>Transaction Number</a:t>
+            </a:r>
+          </a:p>
+          <a:p>
+            <a:pPr marL="742950" lvl="1" indent="-285750">
+              <a:buFont typeface="Arial" panose="020B0604020202020204" pitchFamily="34" charset="0"/>
+              <a:buChar char="•"/>
+            </a:pPr>
+            <a:r>
+              <a:rPr lang="en-US" b="1" dirty="0"/>
+              <a:t>Date &amp; time of payment</a:t>
+            </a:r>
+          </a:p>
+          <a:p>
+            <a:pPr marL="742950" lvl="1" indent="-285750">
+              <a:buFont typeface="Arial" panose="020B0604020202020204" pitchFamily="34" charset="0"/>
+              <a:buChar char="•"/>
+            </a:pPr>
+            <a:endParaRPr lang="en-US" b="1" dirty="0"/>
+          </a:p>
+          <a:p>
+            <a:pPr marL="742950" lvl="1" indent="-285750">
+              <a:buFont typeface="Arial" panose="020B0604020202020204" pitchFamily="34" charset="0"/>
+              <a:buChar char="•"/>
+            </a:pPr>
+            <a:r>
+              <a:rPr lang="en-US" b="1" dirty="0"/>
+              <a:t>Button : Confirm and Decline</a:t>
+            </a:r>
+          </a:p>
+          <a:p>
+            <a:r>
+              <a:rPr lang="en-US" b="1" dirty="0"/>
+              <a:t>}</a:t>
+            </a:r>
+          </a:p>
+        </p:txBody>
+      </p:sp>
     </p:spTree>
     <p:extLst>
       <p:ext uri="{BB962C8B-B14F-4D97-AF65-F5344CB8AC3E}">
@@ -12834,7 +13437,90 @@
 </p:sld>
 </file>
 
-<file path=ppt/slides/slide39.xml><?xml version="1.0" encoding="utf-8"?>
+<file path=ppt/slides/slide4.xml><?xml version="1.0" encoding="utf-8"?>
+<p:sld xmlns:a="http://schemas.openxmlformats.org/drawingml/2006/main" xmlns:r="http://schemas.openxmlformats.org/officeDocument/2006/relationships" xmlns:p="http://schemas.openxmlformats.org/presentationml/2006/main">
+  <p:cSld>
+    <p:spTree>
+      <p:nvGrpSpPr>
+        <p:cNvPr id="1" name=""/>
+        <p:cNvGrpSpPr/>
+        <p:nvPr/>
+      </p:nvGrpSpPr>
+      <p:grpSpPr>
+        <a:xfrm>
+          <a:off x="0" y="0"/>
+          <a:ext cx="0" cy="0"/>
+          <a:chOff x="0" y="0"/>
+          <a:chExt cx="0" cy="0"/>
+        </a:xfrm>
+      </p:grpSpPr>
+      <p:sp>
+        <p:nvSpPr>
+          <p:cNvPr id="2" name="TextBox 1">
+            <a:extLst>
+              <a:ext uri="{FF2B5EF4-FFF2-40B4-BE49-F238E27FC236}">
+                <a16:creationId xmlns:a16="http://schemas.microsoft.com/office/drawing/2014/main" id="{D7905721-4A05-C1B3-9952-8B578834C87C}"/>
+              </a:ext>
+            </a:extLst>
+          </p:cNvPr>
+          <p:cNvSpPr txBox="1"/>
+          <p:nvPr/>
+        </p:nvSpPr>
+        <p:spPr>
+          <a:xfrm>
+            <a:off x="832023" y="2459504"/>
+            <a:ext cx="10527954" cy="1938992"/>
+          </a:xfrm>
+          <a:prstGeom prst="rect">
+            <a:avLst/>
+          </a:prstGeom>
+          <a:noFill/>
+        </p:spPr>
+        <p:txBody>
+          <a:bodyPr wrap="square" rtlCol="0">
+            <a:spAutoFit/>
+          </a:bodyPr>
+          <a:lstStyle/>
+          <a:p>
+            <a:pPr algn="ctr"/>
+            <a:r>
+              <a:rPr lang="en-US" sz="4000" b="1" dirty="0"/>
+              <a:t>All lists or other elements that display data should have </a:t>
+            </a:r>
+            <a:r>
+              <a:rPr lang="en-US" sz="4000" b="1" dirty="0">
+                <a:solidFill>
+                  <a:srgbClr val="C00000"/>
+                </a:solidFill>
+              </a:rPr>
+              <a:t>default CSS Class </a:t>
+            </a:r>
+            <a:r>
+              <a:rPr lang="en-US" sz="4000" b="1" dirty="0"/>
+              <a:t>to toggle the display when there is no content.</a:t>
+            </a:r>
+            <a:endParaRPr lang="en-US" sz="4000" b="1" dirty="0">
+              <a:solidFill>
+                <a:srgbClr val="C00000"/>
+              </a:solidFill>
+            </a:endParaRPr>
+          </a:p>
+        </p:txBody>
+      </p:sp>
+    </p:spTree>
+    <p:extLst>
+      <p:ext uri="{BB962C8B-B14F-4D97-AF65-F5344CB8AC3E}">
+        <p14:creationId xmlns:p14="http://schemas.microsoft.com/office/powerpoint/2010/main" val="2156814539"/>
+      </p:ext>
+    </p:extLst>
+  </p:cSld>
+  <p:clrMapOvr>
+    <a:masterClrMapping/>
+  </p:clrMapOvr>
+</p:sld>
+</file>
+
+<file path=ppt/slides/slide40.xml><?xml version="1.0" encoding="utf-8"?>
 <p:sld xmlns:a="http://schemas.openxmlformats.org/drawingml/2006/main" xmlns:r="http://schemas.openxmlformats.org/officeDocument/2006/relationships" xmlns:p="http://schemas.openxmlformats.org/presentationml/2006/main">
   <p:cSld>
     <p:spTree>
@@ -13070,90 +13756,7 @@
 </p:sld>
 </file>
 
-<file path=ppt/slides/slide4.xml><?xml version="1.0" encoding="utf-8"?>
-<p:sld xmlns:a="http://schemas.openxmlformats.org/drawingml/2006/main" xmlns:r="http://schemas.openxmlformats.org/officeDocument/2006/relationships" xmlns:p="http://schemas.openxmlformats.org/presentationml/2006/main">
-  <p:cSld>
-    <p:spTree>
-      <p:nvGrpSpPr>
-        <p:cNvPr id="1" name=""/>
-        <p:cNvGrpSpPr/>
-        <p:nvPr/>
-      </p:nvGrpSpPr>
-      <p:grpSpPr>
-        <a:xfrm>
-          <a:off x="0" y="0"/>
-          <a:ext cx="0" cy="0"/>
-          <a:chOff x="0" y="0"/>
-          <a:chExt cx="0" cy="0"/>
-        </a:xfrm>
-      </p:grpSpPr>
-      <p:sp>
-        <p:nvSpPr>
-          <p:cNvPr id="2" name="TextBox 1">
-            <a:extLst>
-              <a:ext uri="{FF2B5EF4-FFF2-40B4-BE49-F238E27FC236}">
-                <a16:creationId xmlns:a16="http://schemas.microsoft.com/office/drawing/2014/main" id="{D7905721-4A05-C1B3-9952-8B578834C87C}"/>
-              </a:ext>
-            </a:extLst>
-          </p:cNvPr>
-          <p:cNvSpPr txBox="1"/>
-          <p:nvPr/>
-        </p:nvSpPr>
-        <p:spPr>
-          <a:xfrm>
-            <a:off x="832023" y="2459504"/>
-            <a:ext cx="10527954" cy="1938992"/>
-          </a:xfrm>
-          <a:prstGeom prst="rect">
-            <a:avLst/>
-          </a:prstGeom>
-          <a:noFill/>
-        </p:spPr>
-        <p:txBody>
-          <a:bodyPr wrap="square" rtlCol="0">
-            <a:spAutoFit/>
-          </a:bodyPr>
-          <a:lstStyle/>
-          <a:p>
-            <a:pPr algn="ctr"/>
-            <a:r>
-              <a:rPr lang="en-US" sz="4000" b="1" dirty="0"/>
-              <a:t>All lists or other elements that display data should have </a:t>
-            </a:r>
-            <a:r>
-              <a:rPr lang="en-US" sz="4000" b="1" dirty="0">
-                <a:solidFill>
-                  <a:srgbClr val="C00000"/>
-                </a:solidFill>
-              </a:rPr>
-              <a:t>default CSS Class </a:t>
-            </a:r>
-            <a:r>
-              <a:rPr lang="en-US" sz="4000" b="1" dirty="0"/>
-              <a:t>to toggle the display when there is no content.</a:t>
-            </a:r>
-            <a:endParaRPr lang="en-US" sz="4000" b="1" dirty="0">
-              <a:solidFill>
-                <a:srgbClr val="C00000"/>
-              </a:solidFill>
-            </a:endParaRPr>
-          </a:p>
-        </p:txBody>
-      </p:sp>
-    </p:spTree>
-    <p:extLst>
-      <p:ext uri="{BB962C8B-B14F-4D97-AF65-F5344CB8AC3E}">
-        <p14:creationId xmlns:p14="http://schemas.microsoft.com/office/powerpoint/2010/main" val="2156814539"/>
-      </p:ext>
-    </p:extLst>
-  </p:cSld>
-  <p:clrMapOvr>
-    <a:masterClrMapping/>
-  </p:clrMapOvr>
-</p:sld>
-</file>
-
-<file path=ppt/slides/slide40.xml><?xml version="1.0" encoding="utf-8"?>
+<file path=ppt/slides/slide41.xml><?xml version="1.0" encoding="utf-8"?>
 <p:sld xmlns:a="http://schemas.openxmlformats.org/drawingml/2006/main" xmlns:r="http://schemas.openxmlformats.org/officeDocument/2006/relationships" xmlns:p="http://schemas.openxmlformats.org/presentationml/2006/main">
   <p:cSld>
     <p:spTree>
@@ -13220,7 +13823,7 @@
         <p:spPr>
           <a:xfrm>
             <a:off x="122383" y="267855"/>
-            <a:ext cx="7081981" cy="4137890"/>
+            <a:ext cx="7081981" cy="4100945"/>
           </a:xfrm>
           <a:prstGeom prst="roundRect">
             <a:avLst>
@@ -13369,13 +13972,44 @@
             </a:r>
           </a:p>
           <a:p>
+            <a:pPr lvl="2"/>
+            <a:r>
+              <a:rPr lang="en-US" sz="1600" b="1" dirty="0"/>
+              <a:t>(for check in only)</a:t>
+            </a:r>
+          </a:p>
+          <a:p>
             <a:pPr marL="1200150" lvl="2" indent="-285750">
               <a:buFont typeface="Arial" panose="020B0604020202020204" pitchFamily="34" charset="0"/>
               <a:buChar char="•"/>
             </a:pPr>
             <a:r>
               <a:rPr lang="en-US" sz="1600" b="1" dirty="0"/>
-              <a:t>Button : confirmation of check in and cash payment modal</a:t>
+              <a:t>Button : confirmation of </a:t>
+            </a:r>
+            <a:r>
+              <a:rPr lang="en-US" sz="1600" b="1" dirty="0">
+                <a:solidFill>
+                  <a:srgbClr val="FF0000"/>
+                </a:solidFill>
+              </a:rPr>
+              <a:t>check in </a:t>
+            </a:r>
+            <a:r>
+              <a:rPr lang="en-US" sz="1600" b="1" dirty="0"/>
+              <a:t>and</a:t>
+            </a:r>
+            <a:r>
+              <a:rPr lang="en-US" sz="1600" b="1" dirty="0">
+                <a:solidFill>
+                  <a:srgbClr val="FF0000"/>
+                </a:solidFill>
+              </a:rPr>
+              <a:t> cash payment </a:t>
+            </a:r>
+            <a:r>
+              <a:rPr lang="en-US" sz="1600" b="1" dirty="0"/>
+              <a:t>modal</a:t>
             </a:r>
           </a:p>
           <a:p>
@@ -13385,7 +14019,7 @@
             </a:pPr>
             <a:r>
               <a:rPr lang="en-US" sz="1600" b="1" dirty="0"/>
-              <a:t>Property Name</a:t>
+              <a:t> Property Name</a:t>
             </a:r>
           </a:p>
           <a:p>
@@ -13431,7 +14065,7 @@
             </a:r>
             <a:r>
               <a:rPr lang="en-US" sz="1600" b="1" dirty="0"/>
-              <a:t>)</a:t>
+              <a:t>) for checkout</a:t>
             </a:r>
           </a:p>
           <a:p>
@@ -13889,8 +14523,8 @@
         </p:nvCxnSpPr>
         <p:spPr>
           <a:xfrm flipV="1">
-            <a:off x="5006109" y="3537527"/>
-            <a:ext cx="2932549" cy="471055"/>
+            <a:off x="5089236" y="3537527"/>
+            <a:ext cx="2849422" cy="757382"/>
           </a:xfrm>
           <a:prstGeom prst="curvedConnector3">
             <a:avLst>
@@ -13935,7 +14569,7 @@
 </p:sld>
 </file>
 
-<file path=ppt/slides/slide41.xml><?xml version="1.0" encoding="utf-8"?>
+<file path=ppt/slides/slide42.xml><?xml version="1.0" encoding="utf-8"?>
 <p:sld xmlns:a="http://schemas.openxmlformats.org/drawingml/2006/main" xmlns:r="http://schemas.openxmlformats.org/officeDocument/2006/relationships" xmlns:p="http://schemas.openxmlformats.org/presentationml/2006/main">
   <p:cSld>
     <p:spTree>
@@ -14001,7 +14635,7 @@
 </p:sld>
 </file>
 
-<file path=ppt/slides/slide42.xml><?xml version="1.0" encoding="utf-8"?>
+<file path=ppt/slides/slide43.xml><?xml version="1.0" encoding="utf-8"?>
 <p:sld xmlns:a="http://schemas.openxmlformats.org/drawingml/2006/main" xmlns:r="http://schemas.openxmlformats.org/officeDocument/2006/relationships" xmlns:p="http://schemas.openxmlformats.org/presentationml/2006/main">
   <p:cSld>
     <p:spTree>
@@ -14724,7 +15358,7 @@
 </p:sld>
 </file>
 
-<file path=ppt/slides/slide43.xml><?xml version="1.0" encoding="utf-8"?>
+<file path=ppt/slides/slide44.xml><?xml version="1.0" encoding="utf-8"?>
 <p:sld xmlns:a="http://schemas.openxmlformats.org/drawingml/2006/main" xmlns:r="http://schemas.openxmlformats.org/officeDocument/2006/relationships" xmlns:p="http://schemas.openxmlformats.org/presentationml/2006/main">
   <p:cSld>
     <p:spTree>
@@ -14910,7 +15544,7 @@
 </p:sld>
 </file>
 
-<file path=ppt/slides/slide44.xml><?xml version="1.0" encoding="utf-8"?>
+<file path=ppt/slides/slide45.xml><?xml version="1.0" encoding="utf-8"?>
 <p:sld xmlns:a="http://schemas.openxmlformats.org/drawingml/2006/main" xmlns:r="http://schemas.openxmlformats.org/officeDocument/2006/relationships" xmlns:p="http://schemas.openxmlformats.org/presentationml/2006/main">
   <p:cSld>
     <p:spTree>
@@ -15056,7 +15690,7 @@
 </p:sld>
 </file>
 
-<file path=ppt/slides/slide45.xml><?xml version="1.0" encoding="utf-8"?>
+<file path=ppt/slides/slide46.xml><?xml version="1.0" encoding="utf-8"?>
 <p:sld xmlns:a="http://schemas.openxmlformats.org/drawingml/2006/main" xmlns:r="http://schemas.openxmlformats.org/officeDocument/2006/relationships" xmlns:p="http://schemas.openxmlformats.org/presentationml/2006/main">
   <p:cSld>
     <p:spTree>
@@ -15313,8 +15947,8 @@
         </p:nvSpPr>
         <p:spPr>
           <a:xfrm>
-            <a:off x="6890326" y="2750127"/>
-            <a:ext cx="3962401" cy="1357745"/>
+            <a:off x="6825673" y="101601"/>
+            <a:ext cx="5297056" cy="1173017"/>
           </a:xfrm>
           <a:prstGeom prst="roundRect">
             <a:avLst>
@@ -15366,8 +16000,32 @@
             </a:r>
           </a:p>
           <a:p>
-            <a:pPr lvl="1"/>
-            <a:endParaRPr lang="en-US" sz="1600" b="1" dirty="0"/>
+            <a:pPr marL="742950" lvl="1" indent="-285750">
+              <a:buFont typeface="Arial" panose="020B0604020202020204" pitchFamily="34" charset="0"/>
+              <a:buChar char="•"/>
+            </a:pPr>
+            <a:r>
+              <a:rPr lang="en-US" sz="1600" b="1" dirty="0"/>
+              <a:t>Proceed to payment </a:t>
+            </a:r>
+            <a:r>
+              <a:rPr lang="en-US" sz="1600" b="1" dirty="0" err="1"/>
+              <a:t>Btn</a:t>
+            </a:r>
+            <a:r>
+              <a:rPr lang="en-US" sz="1600" b="1" dirty="0"/>
+              <a:t>: Payment</a:t>
+            </a:r>
+          </a:p>
+          <a:p>
+            <a:pPr marL="742950" lvl="1" indent="-285750">
+              <a:buFont typeface="Arial" panose="020B0604020202020204" pitchFamily="34" charset="0"/>
+              <a:buChar char="•"/>
+            </a:pPr>
+            <a:r>
+              <a:rPr lang="en-US" sz="1600" b="1" dirty="0"/>
+              <a:t>Reservation or Package Payment</a:t>
+            </a:r>
           </a:p>
           <a:p>
             <a:r>
@@ -15377,6 +16035,320 @@
           </a:p>
         </p:txBody>
       </p:sp>
+      <p:sp>
+        <p:nvSpPr>
+          <p:cNvPr id="3" name="Rectangle: Rounded Corners 2">
+            <a:extLst>
+              <a:ext uri="{FF2B5EF4-FFF2-40B4-BE49-F238E27FC236}">
+                <a16:creationId xmlns:a16="http://schemas.microsoft.com/office/drawing/2014/main" id="{338085F6-E2E5-5EAF-D4F0-98EA037E644A}"/>
+              </a:ext>
+            </a:extLst>
+          </p:cNvPr>
+          <p:cNvSpPr/>
+          <p:nvPr/>
+        </p:nvSpPr>
+        <p:spPr>
+          <a:xfrm>
+            <a:off x="6825672" y="1274619"/>
+            <a:ext cx="5297056" cy="5481782"/>
+          </a:xfrm>
+          <a:prstGeom prst="roundRect">
+            <a:avLst>
+              <a:gd name="adj" fmla="val 1311"/>
+            </a:avLst>
+          </a:prstGeom>
+          <a:solidFill>
+            <a:schemeClr val="accent6">
+              <a:lumMod val="50000"/>
+            </a:schemeClr>
+          </a:solidFill>
+          <a:ln>
+            <a:noFill/>
+          </a:ln>
+        </p:spPr>
+        <p:style>
+          <a:lnRef idx="2">
+            <a:schemeClr val="accent1">
+              <a:shade val="15000"/>
+            </a:schemeClr>
+          </a:lnRef>
+          <a:fillRef idx="1">
+            <a:schemeClr val="accent1"/>
+          </a:fillRef>
+          <a:effectRef idx="0">
+            <a:schemeClr val="accent1"/>
+          </a:effectRef>
+          <a:fontRef idx="minor">
+            <a:schemeClr val="lt1"/>
+          </a:fontRef>
+        </p:style>
+        <p:txBody>
+          <a:bodyPr rtlCol="0" anchor="ctr"/>
+          <a:lstStyle/>
+          <a:p>
+            <a:r>
+              <a:rPr lang="en-US" sz="1600" b="1" dirty="0"/>
+              <a:t>guestPayment.html{</a:t>
+            </a:r>
+          </a:p>
+          <a:p>
+            <a:pPr lvl="1"/>
+            <a:r>
+              <a:rPr lang="en-US" sz="1600" b="1" dirty="0"/>
+              <a:t>Section1{</a:t>
+            </a:r>
+          </a:p>
+          <a:p>
+            <a:pPr marL="1200150" lvl="2" indent="-285750">
+              <a:buFont typeface="Arial" panose="020B0604020202020204" pitchFamily="34" charset="0"/>
+              <a:buChar char="•"/>
+            </a:pPr>
+            <a:r>
+              <a:rPr lang="en-US" sz="1600" b="1" dirty="0"/>
+              <a:t>For: Reservation/Full Payment (Dynamic)</a:t>
+            </a:r>
+          </a:p>
+          <a:p>
+            <a:pPr marL="1200150" lvl="2" indent="-285750">
+              <a:buFont typeface="Arial" panose="020B0604020202020204" pitchFamily="34" charset="0"/>
+              <a:buChar char="•"/>
+            </a:pPr>
+            <a:r>
+              <a:rPr lang="en-US" sz="1600" b="1" dirty="0"/>
+              <a:t>Price</a:t>
+            </a:r>
+          </a:p>
+          <a:p>
+            <a:pPr marL="1200150" lvl="2" indent="-285750">
+              <a:buFont typeface="Arial" panose="020B0604020202020204" pitchFamily="34" charset="0"/>
+              <a:buChar char="•"/>
+            </a:pPr>
+            <a:r>
+              <a:rPr lang="en-US" sz="1600" b="1" dirty="0"/>
+              <a:t>Selection (</a:t>
+            </a:r>
+            <a:r>
+              <a:rPr lang="en-US" sz="1600" b="1" dirty="0" err="1"/>
+              <a:t>Gcash</a:t>
+            </a:r>
+            <a:r>
+              <a:rPr lang="en-US" sz="1600" b="1" dirty="0"/>
+              <a:t>, </a:t>
+            </a:r>
+            <a:r>
+              <a:rPr lang="en-US" sz="1600" b="1" dirty="0" err="1"/>
+              <a:t>Gotyme</a:t>
+            </a:r>
+            <a:r>
+              <a:rPr lang="en-US" sz="1600" b="1" dirty="0"/>
+              <a:t>, maya, </a:t>
+            </a:r>
+            <a:r>
+              <a:rPr lang="en-US" sz="1600" b="1" dirty="0" err="1"/>
+              <a:t>UnionBank</a:t>
+            </a:r>
+            <a:r>
+              <a:rPr lang="en-US" sz="1600" b="1" dirty="0"/>
+              <a:t>)</a:t>
+            </a:r>
+          </a:p>
+          <a:p>
+            <a:pPr marL="1200150" lvl="2" indent="-285750">
+              <a:buFont typeface="Arial" panose="020B0604020202020204" pitchFamily="34" charset="0"/>
+              <a:buChar char="•"/>
+            </a:pPr>
+            <a:r>
+              <a:rPr lang="en-US" sz="1600" b="1" dirty="0"/>
+              <a:t>QR Code</a:t>
+            </a:r>
+          </a:p>
+          <a:p>
+            <a:pPr lvl="1"/>
+            <a:r>
+              <a:rPr lang="en-US" sz="1600" b="1" dirty="0"/>
+              <a:t>}</a:t>
+            </a:r>
+          </a:p>
+          <a:p>
+            <a:pPr lvl="1"/>
+            <a:r>
+              <a:rPr lang="en-US" sz="1600" b="1" dirty="0"/>
+              <a:t>Section2{</a:t>
+            </a:r>
+          </a:p>
+          <a:p>
+            <a:pPr marL="1200150" lvl="2" indent="-285750">
+              <a:buFont typeface="Arial" panose="020B0604020202020204" pitchFamily="34" charset="0"/>
+              <a:buChar char="•"/>
+            </a:pPr>
+            <a:r>
+              <a:rPr lang="en-US" sz="1600" b="1" dirty="0"/>
+              <a:t>Text: “Upload a Screenshot”</a:t>
+            </a:r>
+          </a:p>
+          <a:p>
+            <a:pPr marL="1200150" lvl="2" indent="-285750">
+              <a:buFont typeface="Arial" panose="020B0604020202020204" pitchFamily="34" charset="0"/>
+              <a:buChar char="•"/>
+            </a:pPr>
+            <a:r>
+              <a:rPr lang="en-US" sz="1600" b="1" dirty="0"/>
+              <a:t>Upload drag and drop or click the upload button</a:t>
+            </a:r>
+          </a:p>
+          <a:p>
+            <a:pPr marL="1200150" lvl="2" indent="-285750">
+              <a:buFont typeface="Arial" panose="020B0604020202020204" pitchFamily="34" charset="0"/>
+              <a:buChar char="•"/>
+            </a:pPr>
+            <a:r>
+              <a:rPr lang="en-US" sz="1600" b="1" dirty="0"/>
+              <a:t>Image preview</a:t>
+            </a:r>
+          </a:p>
+          <a:p>
+            <a:pPr marL="1200150" lvl="2" indent="-285750">
+              <a:buFont typeface="Arial" panose="020B0604020202020204" pitchFamily="34" charset="0"/>
+              <a:buChar char="•"/>
+            </a:pPr>
+            <a:endParaRPr lang="en-US" sz="1600" b="1" dirty="0"/>
+          </a:p>
+          <a:p>
+            <a:pPr marL="1200150" lvl="2" indent="-285750">
+              <a:buFont typeface="Arial" panose="020B0604020202020204" pitchFamily="34" charset="0"/>
+              <a:buChar char="•"/>
+            </a:pPr>
+            <a:r>
+              <a:rPr lang="en-US" sz="1600" b="1" dirty="0"/>
+              <a:t>Input: // This will populate the transaction#</a:t>
+            </a:r>
+          </a:p>
+          <a:p>
+            <a:pPr marL="1200150" lvl="2" indent="-285750">
+              <a:buFont typeface="Arial" panose="020B0604020202020204" pitchFamily="34" charset="0"/>
+              <a:buChar char="•"/>
+            </a:pPr>
+            <a:r>
+              <a:rPr lang="en-US" sz="1600" b="1" dirty="0"/>
+              <a:t>Button: Confirm Payment</a:t>
+            </a:r>
+          </a:p>
+          <a:p>
+            <a:pPr marL="1200150" lvl="2" indent="-285750">
+              <a:buFont typeface="Arial" panose="020B0604020202020204" pitchFamily="34" charset="0"/>
+              <a:buChar char="•"/>
+            </a:pPr>
+            <a:r>
+              <a:rPr lang="en-US" sz="1400" b="1" dirty="0"/>
+              <a:t>Warning: Please verify the transaction number carefully. It cannot be changed after confirmation, and errors may lead to booking cancellation.</a:t>
+            </a:r>
+          </a:p>
+          <a:p>
+            <a:r>
+              <a:rPr lang="en-US" sz="1600" b="1" dirty="0"/>
+              <a:t>}</a:t>
+            </a:r>
+          </a:p>
+        </p:txBody>
+      </p:sp>
+      <p:cxnSp>
+        <p:nvCxnSpPr>
+          <p:cNvPr id="4" name="Connector: Curved 3">
+            <a:extLst>
+              <a:ext uri="{FF2B5EF4-FFF2-40B4-BE49-F238E27FC236}">
+                <a16:creationId xmlns:a16="http://schemas.microsoft.com/office/drawing/2014/main" id="{D4E191A5-48A4-C58C-B4C0-B608243F776E}"/>
+              </a:ext>
+            </a:extLst>
+          </p:cNvPr>
+          <p:cNvCxnSpPr>
+            <a:cxnSpLocks/>
+          </p:cNvCxnSpPr>
+          <p:nvPr/>
+        </p:nvCxnSpPr>
+        <p:spPr>
+          <a:xfrm rot="10800000" flipV="1">
+            <a:off x="8914247" y="1110675"/>
+            <a:ext cx="685798" cy="623452"/>
+          </a:xfrm>
+          <a:prstGeom prst="curvedConnector3">
+            <a:avLst>
+              <a:gd name="adj1" fmla="val 50000"/>
+            </a:avLst>
+          </a:prstGeom>
+          <a:ln w="19050" cap="flat" cmpd="sng" algn="ctr">
+            <a:solidFill>
+              <a:schemeClr val="accent4"/>
+            </a:solidFill>
+            <a:prstDash val="solid"/>
+            <a:round/>
+            <a:headEnd type="arrow" w="med" len="med"/>
+            <a:tailEnd type="arrow" w="med" len="med"/>
+          </a:ln>
+        </p:spPr>
+        <p:style>
+          <a:lnRef idx="0">
+            <a:scrgbClr r="0" g="0" b="0"/>
+          </a:lnRef>
+          <a:fillRef idx="0">
+            <a:scrgbClr r="0" g="0" b="0"/>
+          </a:fillRef>
+          <a:effectRef idx="0">
+            <a:scrgbClr r="0" g="0" b="0"/>
+          </a:effectRef>
+          <a:fontRef idx="minor">
+            <a:schemeClr val="tx1"/>
+          </a:fontRef>
+        </p:style>
+      </p:cxnSp>
+      <p:cxnSp>
+        <p:nvCxnSpPr>
+          <p:cNvPr id="7" name="Connector: Curved 6">
+            <a:extLst>
+              <a:ext uri="{FF2B5EF4-FFF2-40B4-BE49-F238E27FC236}">
+                <a16:creationId xmlns:a16="http://schemas.microsoft.com/office/drawing/2014/main" id="{47FE4FF9-E8FA-AE95-5756-49769EBF35F5}"/>
+              </a:ext>
+            </a:extLst>
+          </p:cNvPr>
+          <p:cNvCxnSpPr>
+            <a:cxnSpLocks/>
+          </p:cNvCxnSpPr>
+          <p:nvPr/>
+        </p:nvCxnSpPr>
+        <p:spPr>
+          <a:xfrm rot="10800000" flipV="1">
+            <a:off x="1302331" y="300182"/>
+            <a:ext cx="5643414" cy="5394034"/>
+          </a:xfrm>
+          <a:prstGeom prst="curvedConnector3">
+            <a:avLst>
+              <a:gd name="adj1" fmla="val 20213"/>
+            </a:avLst>
+          </a:prstGeom>
+          <a:ln w="19050" cap="flat" cmpd="sng" algn="ctr">
+            <a:solidFill>
+              <a:schemeClr val="accent4"/>
+            </a:solidFill>
+            <a:prstDash val="solid"/>
+            <a:round/>
+            <a:headEnd type="arrow" w="med" len="med"/>
+            <a:tailEnd type="arrow" w="med" len="med"/>
+          </a:ln>
+        </p:spPr>
+        <p:style>
+          <a:lnRef idx="0">
+            <a:scrgbClr r="0" g="0" b="0"/>
+          </a:lnRef>
+          <a:fillRef idx="0">
+            <a:scrgbClr r="0" g="0" b="0"/>
+          </a:fillRef>
+          <a:effectRef idx="0">
+            <a:scrgbClr r="0" g="0" b="0"/>
+          </a:effectRef>
+          <a:fontRef idx="minor">
+            <a:schemeClr val="tx1"/>
+          </a:fontRef>
+        </p:style>
+      </p:cxnSp>
     </p:spTree>
     <p:extLst>
       <p:ext uri="{BB962C8B-B14F-4D97-AF65-F5344CB8AC3E}">
@@ -15390,7 +16362,7 @@
 </p:sld>
 </file>
 
-<file path=ppt/slides/slide46.xml><?xml version="1.0" encoding="utf-8"?>
+<file path=ppt/slides/slide47.xml><?xml version="1.0" encoding="utf-8"?>
 <p:sld xmlns:a="http://schemas.openxmlformats.org/drawingml/2006/main" xmlns:r="http://schemas.openxmlformats.org/officeDocument/2006/relationships" xmlns:p="http://schemas.openxmlformats.org/presentationml/2006/main">
   <p:cSld>
     <p:spTree>
@@ -15684,7 +16656,7 @@
 </p:sld>
 </file>
 
-<file path=ppt/slides/slide47.xml><?xml version="1.0" encoding="utf-8"?>
+<file path=ppt/slides/slide48.xml><?xml version="1.0" encoding="utf-8"?>
 <p:sld xmlns:a="http://schemas.openxmlformats.org/drawingml/2006/main" xmlns:r="http://schemas.openxmlformats.org/officeDocument/2006/relationships" xmlns:p="http://schemas.openxmlformats.org/presentationml/2006/main">
   <p:cSld>
     <p:spTree>
@@ -15989,7 +16961,7 @@
 </p:sld>
 </file>
 
-<file path=ppt/slides/slide48.xml><?xml version="1.0" encoding="utf-8"?>
+<file path=ppt/slides/slide49.xml><?xml version="1.0" encoding="utf-8"?>
 <p:sld xmlns:a="http://schemas.openxmlformats.org/drawingml/2006/main" xmlns:r="http://schemas.openxmlformats.org/officeDocument/2006/relationships" xmlns:p="http://schemas.openxmlformats.org/presentationml/2006/main">
   <p:cSld>
     <p:spTree>
@@ -16259,206 +17231,6 @@
     <p:extLst>
       <p:ext uri="{BB962C8B-B14F-4D97-AF65-F5344CB8AC3E}">
         <p14:creationId xmlns:p14="http://schemas.microsoft.com/office/powerpoint/2010/main" val="1833272379"/>
-      </p:ext>
-    </p:extLst>
-  </p:cSld>
-  <p:clrMapOvr>
-    <a:masterClrMapping/>
-  </p:clrMapOvr>
-</p:sld>
-</file>
-
-<file path=ppt/slides/slide49.xml><?xml version="1.0" encoding="utf-8"?>
-<p:sld xmlns:a="http://schemas.openxmlformats.org/drawingml/2006/main" xmlns:r="http://schemas.openxmlformats.org/officeDocument/2006/relationships" xmlns:p="http://schemas.openxmlformats.org/presentationml/2006/main">
-  <p:cSld>
-    <p:spTree>
-      <p:nvGrpSpPr>
-        <p:cNvPr id="1" name=""/>
-        <p:cNvGrpSpPr/>
-        <p:nvPr/>
-      </p:nvGrpSpPr>
-      <p:grpSpPr>
-        <a:xfrm>
-          <a:off x="0" y="0"/>
-          <a:ext cx="0" cy="0"/>
-          <a:chOff x="0" y="0"/>
-          <a:chExt cx="0" cy="0"/>
-        </a:xfrm>
-      </p:grpSpPr>
-      <p:sp>
-        <p:nvSpPr>
-          <p:cNvPr id="5" name="Rectangle: Rounded Corners 4">
-            <a:extLst>
-              <a:ext uri="{FF2B5EF4-FFF2-40B4-BE49-F238E27FC236}">
-                <a16:creationId xmlns:a16="http://schemas.microsoft.com/office/drawing/2014/main" id="{BADBB24C-5F57-A411-EB25-4559A2AFDB94}"/>
-              </a:ext>
-            </a:extLst>
-          </p:cNvPr>
-          <p:cNvSpPr/>
-          <p:nvPr/>
-        </p:nvSpPr>
-        <p:spPr>
-          <a:xfrm>
-            <a:off x="325581" y="701375"/>
-            <a:ext cx="11540837" cy="5455249"/>
-          </a:xfrm>
-          <a:prstGeom prst="roundRect">
-            <a:avLst>
-              <a:gd name="adj" fmla="val 8182"/>
-            </a:avLst>
-          </a:prstGeom>
-          <a:solidFill>
-            <a:schemeClr val="accent6">
-              <a:lumMod val="50000"/>
-            </a:schemeClr>
-          </a:solidFill>
-          <a:ln>
-            <a:noFill/>
-          </a:ln>
-        </p:spPr>
-        <p:style>
-          <a:lnRef idx="2">
-            <a:schemeClr val="accent1">
-              <a:shade val="15000"/>
-            </a:schemeClr>
-          </a:lnRef>
-          <a:fillRef idx="1">
-            <a:schemeClr val="accent1"/>
-          </a:fillRef>
-          <a:effectRef idx="0">
-            <a:schemeClr val="accent1"/>
-          </a:effectRef>
-          <a:fontRef idx="minor">
-            <a:schemeClr val="lt1"/>
-          </a:fontRef>
-        </p:style>
-        <p:txBody>
-          <a:bodyPr rtlCol="0" anchor="ctr"/>
-          <a:lstStyle/>
-          <a:p>
-            <a:r>
-              <a:rPr lang="en-US" b="1" dirty="0" err="1"/>
-              <a:t>backBtn</a:t>
-            </a:r>
-            <a:r>
-              <a:rPr lang="en-US" b="1" dirty="0"/>
-              <a:t> : Button (guestTickets.html)</a:t>
-            </a:r>
-          </a:p>
-          <a:p>
-            <a:r>
-              <a:rPr lang="en-US" b="1" dirty="0"/>
-              <a:t>Generate a Ticket{</a:t>
-            </a:r>
-          </a:p>
-          <a:p>
-            <a:pPr marL="742950" lvl="1" indent="-285750">
-              <a:buFont typeface="Arial" panose="020B0604020202020204" pitchFamily="34" charset="0"/>
-              <a:buChar char="•"/>
-            </a:pPr>
-            <a:r>
-              <a:rPr lang="en-US" b="1" dirty="0"/>
-              <a:t>Inputs{</a:t>
-            </a:r>
-          </a:p>
-          <a:p>
-            <a:pPr marL="1200150" lvl="2" indent="-285750">
-              <a:buFont typeface="Arial" panose="020B0604020202020204" pitchFamily="34" charset="0"/>
-              <a:buChar char="•"/>
-            </a:pPr>
-            <a:r>
-              <a:rPr lang="en-US" b="1" dirty="0"/>
-              <a:t>Select a Customer Service Agent : (`CS - FirstName`…) : selection</a:t>
-            </a:r>
-          </a:p>
-          <a:p>
-            <a:pPr marL="1200150" lvl="2" indent="-285750">
-              <a:buFont typeface="Arial" panose="020B0604020202020204" pitchFamily="34" charset="0"/>
-              <a:buChar char="•"/>
-            </a:pPr>
-            <a:r>
-              <a:rPr lang="en-US" b="1" dirty="0"/>
-              <a:t>Select a concern : (“Location”, “Appliances”, “Amenities”, “Payment”, “Others”) : selection</a:t>
-            </a:r>
-          </a:p>
-          <a:p>
-            <a:pPr marL="1200150" lvl="2" indent="-285750">
-              <a:buFont typeface="Arial" panose="020B0604020202020204" pitchFamily="34" charset="0"/>
-              <a:buChar char="•"/>
-            </a:pPr>
-            <a:r>
-              <a:rPr lang="en-US" b="1" dirty="0"/>
-              <a:t>Description (min of character ?) : text</a:t>
-            </a:r>
-          </a:p>
-          <a:p>
-            <a:pPr lvl="1"/>
-            <a:r>
-              <a:rPr lang="en-US" b="1" dirty="0"/>
-              <a:t>}</a:t>
-            </a:r>
-          </a:p>
-          <a:p>
-            <a:pPr marL="742950" lvl="1" indent="-285750">
-              <a:buFont typeface="Arial" panose="020B0604020202020204" pitchFamily="34" charset="0"/>
-              <a:buChar char="•"/>
-            </a:pPr>
-            <a:r>
-              <a:rPr lang="en-US" b="1" dirty="0" err="1"/>
-              <a:t>generateBtn</a:t>
-            </a:r>
-            <a:r>
-              <a:rPr lang="en-US" b="1" dirty="0"/>
-              <a:t> : Buttons (API) &gt; go back to guestTickets.html</a:t>
-            </a:r>
-          </a:p>
-          <a:p>
-            <a:r>
-              <a:rPr lang="en-US" b="1" dirty="0"/>
-              <a:t>}</a:t>
-            </a:r>
-          </a:p>
-        </p:txBody>
-      </p:sp>
-      <p:sp>
-        <p:nvSpPr>
-          <p:cNvPr id="4" name="TextBox 3">
-            <a:extLst>
-              <a:ext uri="{FF2B5EF4-FFF2-40B4-BE49-F238E27FC236}">
-                <a16:creationId xmlns:a16="http://schemas.microsoft.com/office/drawing/2014/main" id="{F259B9EF-2882-3D95-7422-68A27385F852}"/>
-              </a:ext>
-            </a:extLst>
-          </p:cNvPr>
-          <p:cNvSpPr txBox="1"/>
-          <p:nvPr/>
-        </p:nvSpPr>
-        <p:spPr>
-          <a:xfrm>
-            <a:off x="-1" y="0"/>
-            <a:ext cx="4341092" cy="400110"/>
-          </a:xfrm>
-          <a:prstGeom prst="rect">
-            <a:avLst/>
-          </a:prstGeom>
-          <a:noFill/>
-        </p:spPr>
-        <p:txBody>
-          <a:bodyPr wrap="square" rtlCol="0">
-            <a:spAutoFit/>
-          </a:bodyPr>
-          <a:lstStyle/>
-          <a:p>
-            <a:r>
-              <a:rPr lang="en-US" sz="2000" b="1" dirty="0"/>
-              <a:t>guestGenerateTicket.html</a:t>
-            </a:r>
-          </a:p>
-        </p:txBody>
-      </p:sp>
-    </p:spTree>
-    <p:extLst>
-      <p:ext uri="{BB962C8B-B14F-4D97-AF65-F5344CB8AC3E}">
-        <p14:creationId xmlns:p14="http://schemas.microsoft.com/office/powerpoint/2010/main" val="3858012836"/>
       </p:ext>
     </p:extLst>
   </p:cSld>
@@ -17044,6 +17816,206 @@
         </p:nvSpPr>
         <p:spPr>
           <a:xfrm>
+            <a:off x="325581" y="701375"/>
+            <a:ext cx="11540837" cy="5455249"/>
+          </a:xfrm>
+          <a:prstGeom prst="roundRect">
+            <a:avLst>
+              <a:gd name="adj" fmla="val 8182"/>
+            </a:avLst>
+          </a:prstGeom>
+          <a:solidFill>
+            <a:schemeClr val="accent6">
+              <a:lumMod val="50000"/>
+            </a:schemeClr>
+          </a:solidFill>
+          <a:ln>
+            <a:noFill/>
+          </a:ln>
+        </p:spPr>
+        <p:style>
+          <a:lnRef idx="2">
+            <a:schemeClr val="accent1">
+              <a:shade val="15000"/>
+            </a:schemeClr>
+          </a:lnRef>
+          <a:fillRef idx="1">
+            <a:schemeClr val="accent1"/>
+          </a:fillRef>
+          <a:effectRef idx="0">
+            <a:schemeClr val="accent1"/>
+          </a:effectRef>
+          <a:fontRef idx="minor">
+            <a:schemeClr val="lt1"/>
+          </a:fontRef>
+        </p:style>
+        <p:txBody>
+          <a:bodyPr rtlCol="0" anchor="ctr"/>
+          <a:lstStyle/>
+          <a:p>
+            <a:r>
+              <a:rPr lang="en-US" b="1" dirty="0" err="1"/>
+              <a:t>backBtn</a:t>
+            </a:r>
+            <a:r>
+              <a:rPr lang="en-US" b="1" dirty="0"/>
+              <a:t> : Button (guestTickets.html)</a:t>
+            </a:r>
+          </a:p>
+          <a:p>
+            <a:r>
+              <a:rPr lang="en-US" b="1" dirty="0"/>
+              <a:t>Generate a Ticket{</a:t>
+            </a:r>
+          </a:p>
+          <a:p>
+            <a:pPr marL="742950" lvl="1" indent="-285750">
+              <a:buFont typeface="Arial" panose="020B0604020202020204" pitchFamily="34" charset="0"/>
+              <a:buChar char="•"/>
+            </a:pPr>
+            <a:r>
+              <a:rPr lang="en-US" b="1" dirty="0"/>
+              <a:t>Inputs{</a:t>
+            </a:r>
+          </a:p>
+          <a:p>
+            <a:pPr marL="1200150" lvl="2" indent="-285750">
+              <a:buFont typeface="Arial" panose="020B0604020202020204" pitchFamily="34" charset="0"/>
+              <a:buChar char="•"/>
+            </a:pPr>
+            <a:r>
+              <a:rPr lang="en-US" b="1" dirty="0"/>
+              <a:t>Select a Customer Service Agent : (`CS - FirstName`…) : selection</a:t>
+            </a:r>
+          </a:p>
+          <a:p>
+            <a:pPr marL="1200150" lvl="2" indent="-285750">
+              <a:buFont typeface="Arial" panose="020B0604020202020204" pitchFamily="34" charset="0"/>
+              <a:buChar char="•"/>
+            </a:pPr>
+            <a:r>
+              <a:rPr lang="en-US" b="1" dirty="0"/>
+              <a:t>Select a concern : (“Location”, “Appliances”, “Amenities”, “Payment”, “Others”) : selection</a:t>
+            </a:r>
+          </a:p>
+          <a:p>
+            <a:pPr marL="1200150" lvl="2" indent="-285750">
+              <a:buFont typeface="Arial" panose="020B0604020202020204" pitchFamily="34" charset="0"/>
+              <a:buChar char="•"/>
+            </a:pPr>
+            <a:r>
+              <a:rPr lang="en-US" b="1" dirty="0"/>
+              <a:t>Description (min of character ?) : text</a:t>
+            </a:r>
+          </a:p>
+          <a:p>
+            <a:pPr lvl="1"/>
+            <a:r>
+              <a:rPr lang="en-US" b="1" dirty="0"/>
+              <a:t>}</a:t>
+            </a:r>
+          </a:p>
+          <a:p>
+            <a:pPr marL="742950" lvl="1" indent="-285750">
+              <a:buFont typeface="Arial" panose="020B0604020202020204" pitchFamily="34" charset="0"/>
+              <a:buChar char="•"/>
+            </a:pPr>
+            <a:r>
+              <a:rPr lang="en-US" b="1" dirty="0" err="1"/>
+              <a:t>generateBtn</a:t>
+            </a:r>
+            <a:r>
+              <a:rPr lang="en-US" b="1" dirty="0"/>
+              <a:t> : Buttons (API) &gt; go back to guestTickets.html</a:t>
+            </a:r>
+          </a:p>
+          <a:p>
+            <a:r>
+              <a:rPr lang="en-US" b="1" dirty="0"/>
+              <a:t>}</a:t>
+            </a:r>
+          </a:p>
+        </p:txBody>
+      </p:sp>
+      <p:sp>
+        <p:nvSpPr>
+          <p:cNvPr id="4" name="TextBox 3">
+            <a:extLst>
+              <a:ext uri="{FF2B5EF4-FFF2-40B4-BE49-F238E27FC236}">
+                <a16:creationId xmlns:a16="http://schemas.microsoft.com/office/drawing/2014/main" id="{F259B9EF-2882-3D95-7422-68A27385F852}"/>
+              </a:ext>
+            </a:extLst>
+          </p:cNvPr>
+          <p:cNvSpPr txBox="1"/>
+          <p:nvPr/>
+        </p:nvSpPr>
+        <p:spPr>
+          <a:xfrm>
+            <a:off x="-1" y="0"/>
+            <a:ext cx="4341092" cy="400110"/>
+          </a:xfrm>
+          <a:prstGeom prst="rect">
+            <a:avLst/>
+          </a:prstGeom>
+          <a:noFill/>
+        </p:spPr>
+        <p:txBody>
+          <a:bodyPr wrap="square" rtlCol="0">
+            <a:spAutoFit/>
+          </a:bodyPr>
+          <a:lstStyle/>
+          <a:p>
+            <a:r>
+              <a:rPr lang="en-US" sz="2000" b="1" dirty="0"/>
+              <a:t>guestGenerateTicket.html</a:t>
+            </a:r>
+          </a:p>
+        </p:txBody>
+      </p:sp>
+    </p:spTree>
+    <p:extLst>
+      <p:ext uri="{BB962C8B-B14F-4D97-AF65-F5344CB8AC3E}">
+        <p14:creationId xmlns:p14="http://schemas.microsoft.com/office/powerpoint/2010/main" val="3858012836"/>
+      </p:ext>
+    </p:extLst>
+  </p:cSld>
+  <p:clrMapOvr>
+    <a:masterClrMapping/>
+  </p:clrMapOvr>
+</p:sld>
+</file>
+
+<file path=ppt/slides/slide51.xml><?xml version="1.0" encoding="utf-8"?>
+<p:sld xmlns:a="http://schemas.openxmlformats.org/drawingml/2006/main" xmlns:r="http://schemas.openxmlformats.org/officeDocument/2006/relationships" xmlns:p="http://schemas.openxmlformats.org/presentationml/2006/main">
+  <p:cSld>
+    <p:spTree>
+      <p:nvGrpSpPr>
+        <p:cNvPr id="1" name=""/>
+        <p:cNvGrpSpPr/>
+        <p:nvPr/>
+      </p:nvGrpSpPr>
+      <p:grpSpPr>
+        <a:xfrm>
+          <a:off x="0" y="0"/>
+          <a:ext cx="0" cy="0"/>
+          <a:chOff x="0" y="0"/>
+          <a:chExt cx="0" cy="0"/>
+        </a:xfrm>
+      </p:grpSpPr>
+      <p:sp>
+        <p:nvSpPr>
+          <p:cNvPr id="5" name="Rectangle: Rounded Corners 4">
+            <a:extLst>
+              <a:ext uri="{FF2B5EF4-FFF2-40B4-BE49-F238E27FC236}">
+                <a16:creationId xmlns:a16="http://schemas.microsoft.com/office/drawing/2014/main" id="{BADBB24C-5F57-A411-EB25-4559A2AFDB94}"/>
+              </a:ext>
+            </a:extLst>
+          </p:cNvPr>
+          <p:cNvSpPr/>
+          <p:nvPr/>
+        </p:nvSpPr>
+        <p:spPr>
+          <a:xfrm>
             <a:off x="4217554" y="2540248"/>
             <a:ext cx="3756892" cy="1777504"/>
           </a:xfrm>
@@ -17172,7 +18144,7 @@
 </p:sld>
 </file>
 
-<file path=ppt/slides/slide51.xml><?xml version="1.0" encoding="utf-8"?>
+<file path=ppt/slides/slide52.xml><?xml version="1.0" encoding="utf-8"?>
 <p:sld xmlns:a="http://schemas.openxmlformats.org/drawingml/2006/main" xmlns:r="http://schemas.openxmlformats.org/officeDocument/2006/relationships" xmlns:p="http://schemas.openxmlformats.org/presentationml/2006/main">
   <p:cSld>
     <p:spTree>
@@ -17321,7 +18293,7 @@
 </p:sld>
 </file>
 
-<file path=ppt/slides/slide52.xml><?xml version="1.0" encoding="utf-8"?>
+<file path=ppt/slides/slide53.xml><?xml version="1.0" encoding="utf-8"?>
 <p:sld xmlns:a="http://schemas.openxmlformats.org/drawingml/2006/main" xmlns:r="http://schemas.openxmlformats.org/officeDocument/2006/relationships" xmlns:p="http://schemas.openxmlformats.org/presentationml/2006/main">
   <p:cSld>
     <p:spTree>
@@ -17570,7 +18542,7 @@
             </a:r>
             <a:r>
               <a:rPr lang="en-US" b="1" dirty="0"/>
-              <a:t>){button: pay remaining balance (redirection)}</a:t>
+              <a:t>){button: pay remaining balance (go to guestPayment.html)}</a:t>
             </a:r>
           </a:p>
           <a:p>
@@ -18637,6 +19609,55 @@
           <a:xfrm flipV="1">
             <a:off x="4368800" y="4836160"/>
             <a:ext cx="629920" cy="447040"/>
+          </a:xfrm>
+          <a:prstGeom prst="curvedConnector3">
+            <a:avLst>
+              <a:gd name="adj1" fmla="val 50000"/>
+            </a:avLst>
+          </a:prstGeom>
+          <a:ln w="19050" cap="flat" cmpd="sng" algn="ctr">
+            <a:solidFill>
+              <a:schemeClr val="accent4"/>
+            </a:solidFill>
+            <a:prstDash val="solid"/>
+            <a:round/>
+            <a:headEnd type="arrow" w="med" len="med"/>
+            <a:tailEnd type="arrow" w="med" len="med"/>
+          </a:ln>
+        </p:spPr>
+        <p:style>
+          <a:lnRef idx="0">
+            <a:scrgbClr r="0" g="0" b="0"/>
+          </a:lnRef>
+          <a:fillRef idx="0">
+            <a:scrgbClr r="0" g="0" b="0"/>
+          </a:fillRef>
+          <a:effectRef idx="0">
+            <a:scrgbClr r="0" g="0" b="0"/>
+          </a:effectRef>
+          <a:fontRef idx="minor">
+            <a:schemeClr val="tx1"/>
+          </a:fontRef>
+        </p:style>
+      </p:cxnSp>
+      <p:cxnSp>
+        <p:nvCxnSpPr>
+          <p:cNvPr id="5" name="Connector: Curved 4">
+            <a:extLst>
+              <a:ext uri="{FF2B5EF4-FFF2-40B4-BE49-F238E27FC236}">
+                <a16:creationId xmlns:a16="http://schemas.microsoft.com/office/drawing/2014/main" id="{1D5BBE9A-8A86-5CDE-9D4D-E222B4AB3CC9}"/>
+              </a:ext>
+            </a:extLst>
+          </p:cNvPr>
+          <p:cNvCxnSpPr>
+            <a:cxnSpLocks/>
+          </p:cNvCxnSpPr>
+          <p:nvPr/>
+        </p:nvCxnSpPr>
+        <p:spPr>
+          <a:xfrm rot="5400000" flipH="1" flipV="1">
+            <a:off x="-193963" y="3740728"/>
+            <a:ext cx="1551709" cy="461818"/>
           </a:xfrm>
           <a:prstGeom prst="curvedConnector3">
             <a:avLst>

</xml_diff>